<commit_message>
Reflect the multi-engine backends on the Future Work slide
The Future Work slide marks MobilityDuck (DuckDB) as a prototype backend and
names the shared substrate the tier serves every engine over: MEOS types, the
MF-JSON / WKB wire format, and a canonical named-function SQL dialect.
</commit_message>
<xml_diff>
--- a/MobilityAPI.pptx
+++ b/MobilityAPI.pptx
@@ -28168,7 +28168,7 @@
                 </a:solidFill>
                 <a:latin typeface="Calibri"/>
               </a:rPr>
-              <a:t>Planned</a:t>
+              <a:t>Prototype</a:t>
             </a:r>
           </a:p>
         </p:txBody>
@@ -28734,7 +28734,7 @@
                 </a:solidFill>
                 <a:latin typeface="Calibri"/>
               </a:rPr>
-              <a:t>shared MEOS types and the MF-JSON / WKB wire format; the same tier fronts transactional databases, streaming engines, and lakehouses</a:t>
+              <a:t>shared MEOS types, the MF-JSON / WKB wire format, and a canonical named-function SQL dialect; the same tier fronts transactional databases, streaming engines, and lakehouses</a:t>
             </a:r>
           </a:p>
         </p:txBody>

</xml_diff>

<commit_message>
Profile each backend engine on its own slide
A per-engine profile slide follows the multi-engine overview for
MobilityDB/PostgreSQL, MobilityDuck/DuckDB and MobilitySpark/Apache Spark,
each laying out the engine's connector, build and deployment, SQL dialect
(identity on all three — the box accessors dispatch stbox vs tbox in one UDF via
the WKB type tag) and sweet spot over the shared card grid. PPTX and PDF updated
together.
</commit_message>
<xml_diff>
--- a/MobilityAPI.pptx
+++ b/MobilityAPI.pptx
@@ -33,6 +33,9 @@
     <p:sldId id="282" r:id="rId24"/>
     <p:sldId id="283" r:id="rId25"/>
     <p:sldId id="278" r:id="rId26"/>
+    <p:sldId id="284" r:id="rId35"/>
+    <p:sldId id="285" r:id="rId36"/>
+    <p:sldId id="286" r:id="rId37"/>
     <p:sldId id="279" r:id="rId27"/>
     <p:sldId id="280" r:id="rId28"/>
     <p:sldId id="281" r:id="rId29"/>
@@ -5031,7 +5034,7 @@
                   <a:srgbClr val="5B6B78"/>
                 </a:solidFill>
               </a:rPr>
-              <a:t>01</a:t>
+              <a:t>1</a:t>
             </a:r>
           </a:p>
         </p:txBody>
@@ -21134,7 +21137,7 @@
                 </a:solidFill>
                 <a:latin typeface="Calibri"/>
               </a:rPr>
-              <a:t>02</a:t>
+              <a:t>2</a:t>
             </a:r>
           </a:p>
         </p:txBody>
@@ -27384,7 +27387,7 @@
                 </a:solidFill>
                 <a:latin typeface="Calibri"/>
               </a:rPr>
-              <a:t>FUTURE WORK</a:t>
+              <a:t>MULTI-ENGINE</a:t>
             </a:r>
           </a:p>
         </p:txBody>
@@ -28164,11 +28167,11 @@
             <a:r>
               <a:rPr sz="1200" b="1" i="0">
                 <a:solidFill>
-                  <a:srgbClr val="5B6B78"/>
-                </a:solidFill>
-                <a:latin typeface="Calibri"/>
-              </a:rPr>
-              <a:t>Prototype</a:t>
+                  <a:srgbClr val="196B24"/>
+                </a:solidFill>
+                <a:latin typeface="Calibri"/>
+              </a:rPr>
+              <a:t>Operational</a:t>
             </a:r>
           </a:p>
         </p:txBody>
@@ -28426,11 +28429,11 @@
             <a:r>
               <a:rPr sz="1200" b="1" i="0">
                 <a:solidFill>
-                  <a:srgbClr val="5B6B78"/>
-                </a:solidFill>
-                <a:latin typeface="Calibri"/>
-              </a:rPr>
-              <a:t>Planned</a:t>
+                  <a:srgbClr val="196B24"/>
+                </a:solidFill>
+                <a:latin typeface="Calibri"/>
+              </a:rPr>
+              <a:t>Operational</a:t>
             </a:r>
           </a:p>
         </p:txBody>
@@ -30740,7 +30743,7 @@
                 </a:solidFill>
                 <a:latin typeface="Calibri"/>
               </a:rPr>
-              <a:t>26</a:t>
+              <a:t>29</a:t>
             </a:r>
           </a:p>
         </p:txBody>
@@ -31005,7 +31008,7 @@
                   <a:srgbClr val="5B6B78"/>
                 </a:solidFill>
               </a:rPr>
-              <a:t>27</a:t>
+              <a:t>30</a:t>
             </a:r>
           </a:p>
         </p:txBody>
@@ -31852,7 +31855,7 @@
                 </a:solidFill>
                 <a:latin typeface="Calibri"/>
               </a:rPr>
-              <a:t>28</a:t>
+              <a:t>31</a:t>
             </a:r>
           </a:p>
         </p:txBody>
@@ -32177,6 +32180,1545 @@
                 <a:hlinkClick r:id="rId7"/>
               </a:rPr>
               <a:t>https://github.com/aistairc/mf-api</a:t>
+            </a:r>
+          </a:p>
+        </p:txBody>
+      </p:sp>
+    </p:spTree>
+  </p:cSld>
+  <p:clrMapOvr>
+    <a:masterClrMapping/>
+  </p:clrMapOvr>
+</p:sld>
+</file>
+
+<file path=ppt/slides/slide29.xml><?xml version="1.0" encoding="utf-8"?>
+<p:sld xmlns:a="http://schemas.openxmlformats.org/drawingml/2006/main" xmlns:p="http://schemas.openxmlformats.org/presentationml/2006/main" xmlns:r="http://schemas.openxmlformats.org/officeDocument/2006/relationships">
+  <p:cSld>
+    <p:spTree>
+      <p:nvGrpSpPr>
+        <p:cNvPr id="1" name=""/>
+        <p:cNvGrpSpPr/>
+        <p:nvPr/>
+      </p:nvGrpSpPr>
+      <p:grpSpPr/>
+      <p:sp>
+        <p:nvSpPr>
+          <p:cNvPr id="2" name="TextBox 1"/>
+          <p:cNvSpPr txBox="1"/>
+          <p:nvPr/>
+        </p:nvSpPr>
+        <p:spPr>
+          <a:xfrm>
+            <a:off x="566928" y="365760"/>
+            <a:ext cx="11057839" cy="274320"/>
+          </a:xfrm>
+          <a:prstGeom prst="rect">
+            <a:avLst/>
+          </a:prstGeom>
+          <a:noFill/>
+        </p:spPr>
+        <p:txBody>
+          <a:bodyPr wrap="square" lIns="0" tIns="0" rIns="0" bIns="0" anchor="t">
+            <a:noAutofit/>
+          </a:bodyPr>
+          <a:lstStyle/>
+          <a:p>
+            <a:pPr algn="l">
+              <a:spcBef>
+                <a:spcPts val="0"/>
+              </a:spcBef>
+              <a:spcAft>
+                <a:spcPts val="200"/>
+              </a:spcAft>
+            </a:pPr>
+            <a:r>
+              <a:rPr sz="1200" b="1" i="0">
+                <a:solidFill>
+                  <a:srgbClr val="156082"/>
+                </a:solidFill>
+                <a:latin typeface="Calibri"/>
+              </a:rPr>
+              <a:t>ENGINE PROFILE</a:t>
+            </a:r>
+          </a:p>
+        </p:txBody>
+      </p:sp>
+      <p:sp>
+        <p:nvSpPr>
+          <p:cNvPr id="3" name="TextBox 2"/>
+          <p:cNvSpPr txBox="1"/>
+          <p:nvPr/>
+        </p:nvSpPr>
+        <p:spPr>
+          <a:xfrm>
+            <a:off x="566928" y="603504"/>
+            <a:ext cx="11057839" cy="777240"/>
+          </a:xfrm>
+          <a:prstGeom prst="rect">
+            <a:avLst/>
+          </a:prstGeom>
+          <a:noFill/>
+        </p:spPr>
+        <p:txBody>
+          <a:bodyPr wrap="square" lIns="0" tIns="0" rIns="0" bIns="0" anchor="t">
+            <a:noAutofit/>
+          </a:bodyPr>
+          <a:lstStyle/>
+          <a:p>
+            <a:pPr algn="l">
+              <a:spcBef>
+                <a:spcPts val="0"/>
+              </a:spcBef>
+              <a:spcAft>
+                <a:spcPts val="200"/>
+              </a:spcAft>
+            </a:pPr>
+            <a:r>
+              <a:rPr sz="3200" b="1" i="0">
+                <a:solidFill>
+                  <a:srgbClr val="0E2841"/>
+                </a:solidFill>
+                <a:latin typeface="Calibri Light"/>
+              </a:rPr>
+              <a:t>MobilityDB  ·  PostgreSQL</a:t>
+            </a:r>
+          </a:p>
+        </p:txBody>
+      </p:sp>
+      <p:sp>
+        <p:nvSpPr>
+          <p:cNvPr id="4" name="Rectangle 3"/>
+          <p:cNvSpPr/>
+          <p:nvPr/>
+        </p:nvSpPr>
+        <p:spPr>
+          <a:xfrm>
+            <a:off x="566928" y="1389888"/>
+            <a:ext cx="1554480" cy="45720"/>
+          </a:xfrm>
+          <a:prstGeom prst="rect">
+            <a:avLst/>
+          </a:prstGeom>
+          <a:solidFill>
+            <a:srgbClr val="156082"/>
+          </a:solidFill>
+          <a:ln>
+            <a:noFill/>
+          </a:ln>
+          <a:effectLst/>
+        </p:spPr>
+        <p:style>
+          <a:lnRef idx="1">
+            <a:schemeClr val="accent1"/>
+          </a:lnRef>
+          <a:fillRef idx="3">
+            <a:schemeClr val="accent1"/>
+          </a:fillRef>
+          <a:effectRef idx="2">
+            <a:schemeClr val="accent1"/>
+          </a:effectRef>
+          <a:fontRef idx="minor">
+            <a:schemeClr val="lt1"/>
+          </a:fontRef>
+        </p:style>
+        <p:txBody>
+          <a:bodyPr rtlCol="0" anchor="ctr"/>
+          <a:lstStyle/>
+          <a:p>
+            <a:pPr algn="ctr"/>
+            <a:endParaRPr/>
+          </a:p>
+        </p:txBody>
+      </p:sp>
+      <p:sp>
+        <p:nvSpPr>
+          <p:cNvPr id="5" name="Rounded Rectangle 4"/>
+          <p:cNvSpPr/>
+          <p:nvPr/>
+        </p:nvSpPr>
+        <p:spPr>
+          <a:xfrm>
+            <a:off x="566928" y="1645920"/>
+            <a:ext cx="11057839" cy="868680"/>
+          </a:xfrm>
+          <a:prstGeom prst="roundRect">
+            <a:avLst>
+              <a:gd name="adj" fmla="val 6000"/>
+            </a:avLst>
+          </a:prstGeom>
+          <a:solidFill>
+            <a:srgbClr val="156082"/>
+          </a:solidFill>
+          <a:ln>
+            <a:noFill/>
+          </a:ln>
+          <a:effectLst/>
+        </p:spPr>
+        <p:style>
+          <a:lnRef idx="1">
+            <a:schemeClr val="accent1"/>
+          </a:lnRef>
+          <a:fillRef idx="3">
+            <a:schemeClr val="accent1"/>
+          </a:fillRef>
+          <a:effectRef idx="2">
+            <a:schemeClr val="accent1"/>
+          </a:effectRef>
+          <a:fontRef idx="minor">
+            <a:schemeClr val="lt1"/>
+          </a:fontRef>
+        </p:style>
+        <p:txBody>
+          <a:bodyPr rtlCol="0" anchor="ctr"/>
+          <a:lstStyle/>
+          <a:p>
+            <a:pPr algn="ctr"/>
+            <a:endParaRPr/>
+          </a:p>
+        </p:txBody>
+      </p:sp>
+      <p:sp>
+        <p:nvSpPr>
+          <p:cNvPr id="6" name="TextBox 5"/>
+          <p:cNvSpPr txBox="1"/>
+          <p:nvPr/>
+        </p:nvSpPr>
+        <p:spPr>
+          <a:xfrm>
+            <a:off x="859536" y="1755648"/>
+            <a:ext cx="10472623" cy="320040"/>
+          </a:xfrm>
+          <a:prstGeom prst="rect">
+            <a:avLst/>
+          </a:prstGeom>
+          <a:noFill/>
+        </p:spPr>
+        <p:txBody>
+          <a:bodyPr wrap="square" lIns="0" tIns="0" rIns="0" bIns="0" anchor="t">
+            <a:noAutofit/>
+          </a:bodyPr>
+          <a:lstStyle/>
+          <a:p>
+            <a:pPr algn="l">
+              <a:spcBef>
+                <a:spcPts val="0"/>
+              </a:spcBef>
+              <a:spcAft>
+                <a:spcPts val="200"/>
+              </a:spcAft>
+            </a:pPr>
+            <a:r>
+              <a:rPr sz="1600" b="1" i="0">
+                <a:solidFill>
+                  <a:srgbClr val="FFFFFF"/>
+                </a:solidFill>
+                <a:latin typeface="Calibri"/>
+              </a:rPr>
+              <a:t>Transactional serving over a live MobilityDB database</a:t>
+            </a:r>
+          </a:p>
+        </p:txBody>
+      </p:sp>
+      <p:sp>
+        <p:nvSpPr>
+          <p:cNvPr id="7" name="TextBox 6"/>
+          <p:cNvSpPr txBox="1"/>
+          <p:nvPr/>
+        </p:nvSpPr>
+        <p:spPr>
+          <a:xfrm>
+            <a:off x="859536" y="2139696"/>
+            <a:ext cx="10472623" cy="274320"/>
+          </a:xfrm>
+          <a:prstGeom prst="rect">
+            <a:avLst/>
+          </a:prstGeom>
+          <a:noFill/>
+        </p:spPr>
+        <p:txBody>
+          <a:bodyPr wrap="square" lIns="0" tIns="0" rIns="0" bIns="0" anchor="t">
+            <a:noAutofit/>
+          </a:bodyPr>
+          <a:lstStyle/>
+          <a:p>
+            <a:pPr algn="l">
+              <a:spcBef>
+                <a:spcPts val="0"/>
+              </a:spcBef>
+              <a:spcAft>
+                <a:spcPts val="200"/>
+              </a:spcAft>
+            </a:pPr>
+            <a:r>
+              <a:rPr sz="1200" b="0" i="0">
+                <a:solidFill>
+                  <a:srgbClr val="CFE2EC"/>
+                </a:solidFill>
+                <a:latin typeface="Calibri"/>
+              </a:rPr>
+              <a:t>The reference OGC output every other engine is matched against</a:t>
+            </a:r>
+          </a:p>
+        </p:txBody>
+      </p:sp>
+      <p:sp>
+        <p:nvSpPr>
+          <p:cNvPr id="8" name="TextBox 7"/>
+          <p:cNvSpPr txBox="1"/>
+          <p:nvPr/>
+        </p:nvSpPr>
+        <p:spPr>
+          <a:xfrm>
+            <a:off x="566928" y="2633472"/>
+            <a:ext cx="11057839" cy="274320"/>
+          </a:xfrm>
+          <a:prstGeom prst="rect">
+            <a:avLst/>
+          </a:prstGeom>
+          <a:noFill/>
+        </p:spPr>
+        <p:txBody>
+          <a:bodyPr wrap="square" lIns="0" tIns="0" rIns="0" bIns="0" anchor="t">
+            <a:noAutofit/>
+          </a:bodyPr>
+          <a:lstStyle/>
+          <a:p>
+            <a:pPr algn="ctr">
+              <a:spcBef>
+                <a:spcPts val="0"/>
+              </a:spcBef>
+              <a:spcAft>
+                <a:spcPts val="200"/>
+              </a:spcAft>
+            </a:pPr>
+            <a:r>
+              <a:rPr sz="1200" b="0" i="0">
+                <a:solidFill>
+                  <a:srgbClr val="5B6B78"/>
+                </a:solidFill>
+                <a:latin typeface="Calibri"/>
+              </a:rPr>
+              <a:t>▼   the engine is a configuration choice — a DSN scheme and a build tag select it</a:t>
+            </a:r>
+          </a:p>
+        </p:txBody>
+      </p:sp>
+      <p:sp>
+        <p:nvSpPr>
+          <p:cNvPr id="9" name="Rounded Rectangle 8"/>
+          <p:cNvSpPr/>
+          <p:nvPr/>
+        </p:nvSpPr>
+        <p:spPr>
+          <a:xfrm>
+            <a:off x="566928" y="3108960"/>
+            <a:ext cx="2558719" cy="2331720"/>
+          </a:xfrm>
+          <a:prstGeom prst="roundRect">
+            <a:avLst>
+              <a:gd name="adj" fmla="val 5000"/>
+            </a:avLst>
+          </a:prstGeom>
+          <a:solidFill>
+            <a:srgbClr val="F1F5F8"/>
+          </a:solidFill>
+          <a:ln>
+            <a:noFill/>
+          </a:ln>
+          <a:effectLst/>
+        </p:spPr>
+        <p:style>
+          <a:lnRef idx="1">
+            <a:schemeClr val="accent1"/>
+          </a:lnRef>
+          <a:fillRef idx="3">
+            <a:schemeClr val="accent1"/>
+          </a:fillRef>
+          <a:effectRef idx="2">
+            <a:schemeClr val="accent1"/>
+          </a:effectRef>
+          <a:fontRef idx="minor">
+            <a:schemeClr val="lt1"/>
+          </a:fontRef>
+        </p:style>
+        <p:txBody>
+          <a:bodyPr rtlCol="0" anchor="ctr"/>
+          <a:lstStyle/>
+          <a:p>
+            <a:pPr algn="ctr"/>
+            <a:endParaRPr/>
+          </a:p>
+        </p:txBody>
+      </p:sp>
+      <p:sp>
+        <p:nvSpPr>
+          <p:cNvPr id="10" name="Rounded Rectangle 9"/>
+          <p:cNvSpPr/>
+          <p:nvPr/>
+        </p:nvSpPr>
+        <p:spPr>
+          <a:xfrm>
+            <a:off x="566928" y="3108960"/>
+            <a:ext cx="2558719" cy="475488"/>
+          </a:xfrm>
+          <a:prstGeom prst="roundRect">
+            <a:avLst>
+              <a:gd name="adj" fmla="val 8000"/>
+            </a:avLst>
+          </a:prstGeom>
+          <a:solidFill>
+            <a:srgbClr val="156082"/>
+          </a:solidFill>
+          <a:ln>
+            <a:noFill/>
+          </a:ln>
+          <a:effectLst/>
+        </p:spPr>
+        <p:style>
+          <a:lnRef idx="1">
+            <a:schemeClr val="accent1"/>
+          </a:lnRef>
+          <a:fillRef idx="3">
+            <a:schemeClr val="accent1"/>
+          </a:fillRef>
+          <a:effectRef idx="2">
+            <a:schemeClr val="accent1"/>
+          </a:effectRef>
+          <a:fontRef idx="minor">
+            <a:schemeClr val="lt1"/>
+          </a:fontRef>
+        </p:style>
+        <p:txBody>
+          <a:bodyPr rtlCol="0" anchor="ctr"/>
+          <a:lstStyle/>
+          <a:p>
+            <a:pPr algn="ctr"/>
+            <a:endParaRPr/>
+          </a:p>
+        </p:txBody>
+      </p:sp>
+      <p:sp>
+        <p:nvSpPr>
+          <p:cNvPr id="11" name="TextBox 10"/>
+          <p:cNvSpPr txBox="1"/>
+          <p:nvPr/>
+        </p:nvSpPr>
+        <p:spPr>
+          <a:xfrm>
+            <a:off x="731520" y="3163824"/>
+            <a:ext cx="2284399" cy="365760"/>
+          </a:xfrm>
+          <a:prstGeom prst="rect">
+            <a:avLst/>
+          </a:prstGeom>
+          <a:noFill/>
+        </p:spPr>
+        <p:txBody>
+          <a:bodyPr wrap="square" lIns="0" tIns="0" rIns="0" bIns="0" anchor="ctr">
+            <a:noAutofit/>
+          </a:bodyPr>
+          <a:lstStyle/>
+          <a:p>
+            <a:pPr algn="l">
+              <a:spcBef>
+                <a:spcPts val="0"/>
+              </a:spcBef>
+              <a:spcAft>
+                <a:spcPts val="200"/>
+              </a:spcAft>
+            </a:pPr>
+            <a:r>
+              <a:rPr sz="1400" b="1" i="0">
+                <a:solidFill>
+                  <a:srgbClr val="FFFFFF"/>
+                </a:solidFill>
+                <a:latin typeface="Calibri"/>
+              </a:rPr>
+              <a:t>Connector</a:t>
+            </a:r>
+          </a:p>
+        </p:txBody>
+      </p:sp>
+      <p:sp>
+        <p:nvSpPr>
+          <p:cNvPr id="12" name="TextBox 11"/>
+          <p:cNvSpPr txBox="1"/>
+          <p:nvPr/>
+        </p:nvSpPr>
+        <p:spPr>
+          <a:xfrm>
+            <a:off x="731520" y="3703320"/>
+            <a:ext cx="2284399" cy="274320"/>
+          </a:xfrm>
+          <a:prstGeom prst="rect">
+            <a:avLst/>
+          </a:prstGeom>
+          <a:noFill/>
+        </p:spPr>
+        <p:txBody>
+          <a:bodyPr wrap="square" lIns="0" tIns="0" rIns="0" bIns="0" anchor="t">
+            <a:noAutofit/>
+          </a:bodyPr>
+          <a:lstStyle/>
+          <a:p>
+            <a:pPr algn="l">
+              <a:spcBef>
+                <a:spcPts val="0"/>
+              </a:spcBef>
+              <a:spcAft>
+                <a:spcPts val="200"/>
+              </a:spcAft>
+            </a:pPr>
+            <a:r>
+              <a:rPr sz="1200" b="1" i="0">
+                <a:solidFill>
+                  <a:srgbClr val="156082"/>
+                </a:solidFill>
+                <a:latin typeface="Consolas"/>
+              </a:rPr>
+              <a:t>pgx pool</a:t>
+            </a:r>
+          </a:p>
+        </p:txBody>
+      </p:sp>
+      <p:sp>
+        <p:nvSpPr>
+          <p:cNvPr id="13" name="TextBox 12"/>
+          <p:cNvSpPr txBox="1"/>
+          <p:nvPr/>
+        </p:nvSpPr>
+        <p:spPr>
+          <a:xfrm>
+            <a:off x="731520" y="4041648"/>
+            <a:ext cx="2229535" cy="914400"/>
+          </a:xfrm>
+          <a:prstGeom prst="rect">
+            <a:avLst/>
+          </a:prstGeom>
+          <a:noFill/>
+        </p:spPr>
+        <p:txBody>
+          <a:bodyPr wrap="square" lIns="0" tIns="0" rIns="0" bIns="0" anchor="t">
+            <a:noAutofit/>
+          </a:bodyPr>
+          <a:lstStyle/>
+          <a:p>
+            <a:pPr algn="l">
+              <a:spcBef>
+                <a:spcPts val="0"/>
+              </a:spcBef>
+              <a:spcAft>
+                <a:spcPts val="200"/>
+              </a:spcAft>
+            </a:pPr>
+            <a:r>
+              <a:rPr sz="1200" b="0" i="0">
+                <a:solidFill>
+                  <a:srgbClr val="1E2B36"/>
+                </a:solidFill>
+                <a:latin typeface="Calibri"/>
+              </a:rPr>
+              <a:t>Live server connection; pgx.ErrNoRows maps onto the tier's ErrNoRows.</a:t>
+            </a:r>
+          </a:p>
+        </p:txBody>
+      </p:sp>
+      <p:sp>
+        <p:nvSpPr>
+          <p:cNvPr id="14" name="TextBox 13"/>
+          <p:cNvSpPr txBox="1"/>
+          <p:nvPr/>
+        </p:nvSpPr>
+        <p:spPr>
+          <a:xfrm>
+            <a:off x="731520" y="5074920"/>
+            <a:ext cx="2284399" cy="274320"/>
+          </a:xfrm>
+          <a:prstGeom prst="rect">
+            <a:avLst/>
+          </a:prstGeom>
+          <a:noFill/>
+        </p:spPr>
+        <p:txBody>
+          <a:bodyPr wrap="square" lIns="0" tIns="0" rIns="0" bIns="0" anchor="t">
+            <a:noAutofit/>
+          </a:bodyPr>
+          <a:lstStyle/>
+          <a:p>
+            <a:pPr algn="l">
+              <a:spcBef>
+                <a:spcPts val="0"/>
+              </a:spcBef>
+              <a:spcAft>
+                <a:spcPts val="200"/>
+              </a:spcAft>
+            </a:pPr>
+            <a:r>
+              <a:rPr sz="1200" b="1" i="0">
+                <a:solidFill>
+                  <a:srgbClr val="5B6B78"/>
+                </a:solidFill>
+                <a:latin typeface="Calibri"/>
+              </a:rPr>
+              <a:t>server</a:t>
+            </a:r>
+          </a:p>
+        </p:txBody>
+      </p:sp>
+      <p:sp>
+        <p:nvSpPr>
+          <p:cNvPr id="15" name="Rounded Rectangle 14"/>
+          <p:cNvSpPr/>
+          <p:nvPr/>
+        </p:nvSpPr>
+        <p:spPr>
+          <a:xfrm>
+            <a:off x="3399967" y="3108960"/>
+            <a:ext cx="2558719" cy="2331720"/>
+          </a:xfrm>
+          <a:prstGeom prst="roundRect">
+            <a:avLst>
+              <a:gd name="adj" fmla="val 5000"/>
+            </a:avLst>
+          </a:prstGeom>
+          <a:solidFill>
+            <a:srgbClr val="F1F5F8"/>
+          </a:solidFill>
+          <a:ln>
+            <a:noFill/>
+          </a:ln>
+          <a:effectLst/>
+        </p:spPr>
+        <p:style>
+          <a:lnRef idx="1">
+            <a:schemeClr val="accent1"/>
+          </a:lnRef>
+          <a:fillRef idx="3">
+            <a:schemeClr val="accent1"/>
+          </a:fillRef>
+          <a:effectRef idx="2">
+            <a:schemeClr val="accent1"/>
+          </a:effectRef>
+          <a:fontRef idx="minor">
+            <a:schemeClr val="lt1"/>
+          </a:fontRef>
+        </p:style>
+        <p:txBody>
+          <a:bodyPr rtlCol="0" anchor="ctr"/>
+          <a:lstStyle/>
+          <a:p>
+            <a:pPr algn="ctr"/>
+            <a:endParaRPr/>
+          </a:p>
+        </p:txBody>
+      </p:sp>
+      <p:sp>
+        <p:nvSpPr>
+          <p:cNvPr id="16" name="Rounded Rectangle 15"/>
+          <p:cNvSpPr/>
+          <p:nvPr/>
+        </p:nvSpPr>
+        <p:spPr>
+          <a:xfrm>
+            <a:off x="3399967" y="3108960"/>
+            <a:ext cx="2558719" cy="475488"/>
+          </a:xfrm>
+          <a:prstGeom prst="roundRect">
+            <a:avLst>
+              <a:gd name="adj" fmla="val 8000"/>
+            </a:avLst>
+          </a:prstGeom>
+          <a:solidFill>
+            <a:srgbClr val="196B24"/>
+          </a:solidFill>
+          <a:ln>
+            <a:noFill/>
+          </a:ln>
+          <a:effectLst/>
+        </p:spPr>
+        <p:style>
+          <a:lnRef idx="1">
+            <a:schemeClr val="accent1"/>
+          </a:lnRef>
+          <a:fillRef idx="3">
+            <a:schemeClr val="accent1"/>
+          </a:fillRef>
+          <a:effectRef idx="2">
+            <a:schemeClr val="accent1"/>
+          </a:effectRef>
+          <a:fontRef idx="minor">
+            <a:schemeClr val="lt1"/>
+          </a:fontRef>
+        </p:style>
+        <p:txBody>
+          <a:bodyPr rtlCol="0" anchor="ctr"/>
+          <a:lstStyle/>
+          <a:p>
+            <a:pPr algn="ctr"/>
+            <a:endParaRPr/>
+          </a:p>
+        </p:txBody>
+      </p:sp>
+      <p:sp>
+        <p:nvSpPr>
+          <p:cNvPr id="17" name="TextBox 16"/>
+          <p:cNvSpPr txBox="1"/>
+          <p:nvPr/>
+        </p:nvSpPr>
+        <p:spPr>
+          <a:xfrm>
+            <a:off x="3564559" y="3163824"/>
+            <a:ext cx="2284399" cy="365760"/>
+          </a:xfrm>
+          <a:prstGeom prst="rect">
+            <a:avLst/>
+          </a:prstGeom>
+          <a:noFill/>
+        </p:spPr>
+        <p:txBody>
+          <a:bodyPr wrap="square" lIns="0" tIns="0" rIns="0" bIns="0" anchor="ctr">
+            <a:noAutofit/>
+          </a:bodyPr>
+          <a:lstStyle/>
+          <a:p>
+            <a:pPr algn="l">
+              <a:spcBef>
+                <a:spcPts val="0"/>
+              </a:spcBef>
+              <a:spcAft>
+                <a:spcPts val="200"/>
+              </a:spcAft>
+            </a:pPr>
+            <a:r>
+              <a:rPr sz="1400" b="1" i="0">
+                <a:solidFill>
+                  <a:srgbClr val="FFFFFF"/>
+                </a:solidFill>
+                <a:latin typeface="Calibri"/>
+              </a:rPr>
+              <a:t>Build &amp; deploy</a:t>
+            </a:r>
+          </a:p>
+        </p:txBody>
+      </p:sp>
+      <p:sp>
+        <p:nvSpPr>
+          <p:cNvPr id="18" name="TextBox 17"/>
+          <p:cNvSpPr txBox="1"/>
+          <p:nvPr/>
+        </p:nvSpPr>
+        <p:spPr>
+          <a:xfrm>
+            <a:off x="3564559" y="3703320"/>
+            <a:ext cx="2284399" cy="274320"/>
+          </a:xfrm>
+          <a:prstGeom prst="rect">
+            <a:avLst/>
+          </a:prstGeom>
+          <a:noFill/>
+        </p:spPr>
+        <p:txBody>
+          <a:bodyPr wrap="square" lIns="0" tIns="0" rIns="0" bIns="0" anchor="t">
+            <a:noAutofit/>
+          </a:bodyPr>
+          <a:lstStyle/>
+          <a:p>
+            <a:pPr algn="l">
+              <a:spcBef>
+                <a:spcPts val="0"/>
+              </a:spcBef>
+              <a:spcAft>
+                <a:spcPts val="200"/>
+              </a:spcAft>
+            </a:pPr>
+            <a:r>
+              <a:rPr sz="1200" b="1" i="0">
+                <a:solidFill>
+                  <a:srgbClr val="196B24"/>
+                </a:solidFill>
+                <a:latin typeface="Consolas"/>
+              </a:rPr>
+              <a:t>static binary</a:t>
+            </a:r>
+          </a:p>
+        </p:txBody>
+      </p:sp>
+      <p:sp>
+        <p:nvSpPr>
+          <p:cNvPr id="19" name="TextBox 18"/>
+          <p:cNvSpPr txBox="1"/>
+          <p:nvPr/>
+        </p:nvSpPr>
+        <p:spPr>
+          <a:xfrm>
+            <a:off x="3564559" y="4041648"/>
+            <a:ext cx="2229535" cy="914400"/>
+          </a:xfrm>
+          <a:prstGeom prst="rect">
+            <a:avLst/>
+          </a:prstGeom>
+          <a:noFill/>
+        </p:spPr>
+        <p:txBody>
+          <a:bodyPr wrap="square" lIns="0" tIns="0" rIns="0" bIns="0" anchor="t">
+            <a:noAutofit/>
+          </a:bodyPr>
+          <a:lstStyle/>
+          <a:p>
+            <a:pPr algn="l">
+              <a:spcBef>
+                <a:spcPts val="0"/>
+              </a:spcBef>
+              <a:spcAft>
+                <a:spcPts val="200"/>
+              </a:spcAft>
+            </a:pPr>
+            <a:r>
+              <a:rPr sz="1200" b="0" i="0">
+                <a:solidFill>
+                  <a:srgbClr val="1E2B36"/>
+                </a:solidFill>
+                <a:latin typeface="Calibri"/>
+              </a:rPr>
+              <a:t>Default build — static and cgo-free; no engine libraries linked.</a:t>
+            </a:r>
+          </a:p>
+        </p:txBody>
+      </p:sp>
+      <p:sp>
+        <p:nvSpPr>
+          <p:cNvPr id="20" name="TextBox 19"/>
+          <p:cNvSpPr txBox="1"/>
+          <p:nvPr/>
+        </p:nvSpPr>
+        <p:spPr>
+          <a:xfrm>
+            <a:off x="3564559" y="5074920"/>
+            <a:ext cx="2284399" cy="274320"/>
+          </a:xfrm>
+          <a:prstGeom prst="rect">
+            <a:avLst/>
+          </a:prstGeom>
+          <a:noFill/>
+        </p:spPr>
+        <p:txBody>
+          <a:bodyPr wrap="square" lIns="0" tIns="0" rIns="0" bIns="0" anchor="t">
+            <a:noAutofit/>
+          </a:bodyPr>
+          <a:lstStyle/>
+          <a:p>
+            <a:pPr algn="l">
+              <a:spcBef>
+                <a:spcPts val="0"/>
+              </a:spcBef>
+              <a:spcAft>
+                <a:spcPts val="200"/>
+              </a:spcAft>
+            </a:pPr>
+            <a:r>
+              <a:rPr sz="1200" b="1" i="0">
+                <a:solidFill>
+                  <a:srgbClr val="5B6B78"/>
+                </a:solidFill>
+                <a:latin typeface="Calibri"/>
+              </a:rPr>
+              <a:t>default</a:t>
+            </a:r>
+          </a:p>
+        </p:txBody>
+      </p:sp>
+      <p:sp>
+        <p:nvSpPr>
+          <p:cNvPr id="21" name="Rounded Rectangle 20"/>
+          <p:cNvSpPr/>
+          <p:nvPr/>
+        </p:nvSpPr>
+        <p:spPr>
+          <a:xfrm>
+            <a:off x="6233007" y="3108960"/>
+            <a:ext cx="2558719" cy="2331720"/>
+          </a:xfrm>
+          <a:prstGeom prst="roundRect">
+            <a:avLst>
+              <a:gd name="adj" fmla="val 5000"/>
+            </a:avLst>
+          </a:prstGeom>
+          <a:solidFill>
+            <a:srgbClr val="F1F5F8"/>
+          </a:solidFill>
+          <a:ln>
+            <a:noFill/>
+          </a:ln>
+          <a:effectLst/>
+        </p:spPr>
+        <p:style>
+          <a:lnRef idx="1">
+            <a:schemeClr val="accent1"/>
+          </a:lnRef>
+          <a:fillRef idx="3">
+            <a:schemeClr val="accent1"/>
+          </a:fillRef>
+          <a:effectRef idx="2">
+            <a:schemeClr val="accent1"/>
+          </a:effectRef>
+          <a:fontRef idx="minor">
+            <a:schemeClr val="lt1"/>
+          </a:fontRef>
+        </p:style>
+        <p:txBody>
+          <a:bodyPr rtlCol="0" anchor="ctr"/>
+          <a:lstStyle/>
+          <a:p>
+            <a:pPr algn="ctr"/>
+            <a:endParaRPr/>
+          </a:p>
+        </p:txBody>
+      </p:sp>
+      <p:sp>
+        <p:nvSpPr>
+          <p:cNvPr id="22" name="Rounded Rectangle 21"/>
+          <p:cNvSpPr/>
+          <p:nvPr/>
+        </p:nvSpPr>
+        <p:spPr>
+          <a:xfrm>
+            <a:off x="6233007" y="3108960"/>
+            <a:ext cx="2558719" cy="475488"/>
+          </a:xfrm>
+          <a:prstGeom prst="roundRect">
+            <a:avLst>
+              <a:gd name="adj" fmla="val 8000"/>
+            </a:avLst>
+          </a:prstGeom>
+          <a:solidFill>
+            <a:srgbClr val="E97132"/>
+          </a:solidFill>
+          <a:ln>
+            <a:noFill/>
+          </a:ln>
+          <a:effectLst/>
+        </p:spPr>
+        <p:style>
+          <a:lnRef idx="1">
+            <a:schemeClr val="accent1"/>
+          </a:lnRef>
+          <a:fillRef idx="3">
+            <a:schemeClr val="accent1"/>
+          </a:fillRef>
+          <a:effectRef idx="2">
+            <a:schemeClr val="accent1"/>
+          </a:effectRef>
+          <a:fontRef idx="minor">
+            <a:schemeClr val="lt1"/>
+          </a:fontRef>
+        </p:style>
+        <p:txBody>
+          <a:bodyPr rtlCol="0" anchor="ctr"/>
+          <a:lstStyle/>
+          <a:p>
+            <a:pPr algn="ctr"/>
+            <a:endParaRPr/>
+          </a:p>
+        </p:txBody>
+      </p:sp>
+      <p:sp>
+        <p:nvSpPr>
+          <p:cNvPr id="23" name="TextBox 22"/>
+          <p:cNvSpPr txBox="1"/>
+          <p:nvPr/>
+        </p:nvSpPr>
+        <p:spPr>
+          <a:xfrm>
+            <a:off x="6397599" y="3163824"/>
+            <a:ext cx="2284399" cy="365760"/>
+          </a:xfrm>
+          <a:prstGeom prst="rect">
+            <a:avLst/>
+          </a:prstGeom>
+          <a:noFill/>
+        </p:spPr>
+        <p:txBody>
+          <a:bodyPr wrap="square" lIns="0" tIns="0" rIns="0" bIns="0" anchor="ctr">
+            <a:noAutofit/>
+          </a:bodyPr>
+          <a:lstStyle/>
+          <a:p>
+            <a:pPr algn="l">
+              <a:spcBef>
+                <a:spcPts val="0"/>
+              </a:spcBef>
+              <a:spcAft>
+                <a:spcPts val="200"/>
+              </a:spcAft>
+            </a:pPr>
+            <a:r>
+              <a:rPr sz="1400" b="1" i="0">
+                <a:solidFill>
+                  <a:srgbClr val="FFFFFF"/>
+                </a:solidFill>
+                <a:latin typeface="Calibri"/>
+              </a:rPr>
+              <a:t>SQL dialect</a:t>
+            </a:r>
+          </a:p>
+        </p:txBody>
+      </p:sp>
+      <p:sp>
+        <p:nvSpPr>
+          <p:cNvPr id="24" name="TextBox 23"/>
+          <p:cNvSpPr txBox="1"/>
+          <p:nvPr/>
+        </p:nvSpPr>
+        <p:spPr>
+          <a:xfrm>
+            <a:off x="6397599" y="3703320"/>
+            <a:ext cx="2284399" cy="274320"/>
+          </a:xfrm>
+          <a:prstGeom prst="rect">
+            <a:avLst/>
+          </a:prstGeom>
+          <a:noFill/>
+        </p:spPr>
+        <p:txBody>
+          <a:bodyPr wrap="square" lIns="0" tIns="0" rIns="0" bIns="0" anchor="t">
+            <a:noAutofit/>
+          </a:bodyPr>
+          <a:lstStyle/>
+          <a:p>
+            <a:pPr algn="l">
+              <a:spcBef>
+                <a:spcPts val="0"/>
+              </a:spcBef>
+              <a:spcAft>
+                <a:spcPts val="200"/>
+              </a:spcAft>
+            </a:pPr>
+            <a:r>
+              <a:rPr sz="1200" b="1" i="0">
+                <a:solidFill>
+                  <a:srgbClr val="E97132"/>
+                </a:solidFill>
+                <a:latin typeface="Consolas"/>
+              </a:rPr>
+              <a:t>identity</a:t>
+            </a:r>
+          </a:p>
+        </p:txBody>
+      </p:sp>
+      <p:sp>
+        <p:nvSpPr>
+          <p:cNvPr id="25" name="TextBox 24"/>
+          <p:cNvSpPr txBox="1"/>
+          <p:nvPr/>
+        </p:nvSpPr>
+        <p:spPr>
+          <a:xfrm>
+            <a:off x="6397599" y="4041648"/>
+            <a:ext cx="2229535" cy="914400"/>
+          </a:xfrm>
+          <a:prstGeom prst="rect">
+            <a:avLst/>
+          </a:prstGeom>
+          <a:noFill/>
+        </p:spPr>
+        <p:txBody>
+          <a:bodyPr wrap="square" lIns="0" tIns="0" rIns="0" bIns="0" anchor="t">
+            <a:noAutofit/>
+          </a:bodyPr>
+          <a:lstStyle/>
+          <a:p>
+            <a:pPr algn="l">
+              <a:spcBef>
+                <a:spcPts val="0"/>
+              </a:spcBef>
+              <a:spcAft>
+                <a:spcPts val="200"/>
+              </a:spcAft>
+            </a:pPr>
+            <a:r>
+              <a:rPr sz="1200" b="0" i="0">
+                <a:solidFill>
+                  <a:srgbClr val="1E2B36"/>
+                </a:solidFill>
+                <a:latin typeface="Calibri"/>
+              </a:rPr>
+              <a:t>Canonical named-function SQL runs as-is; no name or type translation.</a:t>
+            </a:r>
+          </a:p>
+        </p:txBody>
+      </p:sp>
+      <p:sp>
+        <p:nvSpPr>
+          <p:cNvPr id="26" name="TextBox 25"/>
+          <p:cNvSpPr txBox="1"/>
+          <p:nvPr/>
+        </p:nvSpPr>
+        <p:spPr>
+          <a:xfrm>
+            <a:off x="6397599" y="5074920"/>
+            <a:ext cx="2284399" cy="274320"/>
+          </a:xfrm>
+          <a:prstGeom prst="rect">
+            <a:avLst/>
+          </a:prstGeom>
+          <a:noFill/>
+        </p:spPr>
+        <p:txBody>
+          <a:bodyPr wrap="square" lIns="0" tIns="0" rIns="0" bIns="0" anchor="t">
+            <a:noAutofit/>
+          </a:bodyPr>
+          <a:lstStyle/>
+          <a:p>
+            <a:pPr algn="l">
+              <a:spcBef>
+                <a:spcPts val="0"/>
+              </a:spcBef>
+              <a:spcAft>
+                <a:spcPts val="200"/>
+              </a:spcAft>
+            </a:pPr>
+            <a:r>
+              <a:rPr sz="1200" b="1" i="0">
+                <a:solidFill>
+                  <a:srgbClr val="5B6B78"/>
+                </a:solidFill>
+                <a:latin typeface="Calibri"/>
+              </a:rPr>
+              <a:t>as-is</a:t>
+            </a:r>
+          </a:p>
+        </p:txBody>
+      </p:sp>
+      <p:sp>
+        <p:nvSpPr>
+          <p:cNvPr id="27" name="Rounded Rectangle 26"/>
+          <p:cNvSpPr/>
+          <p:nvPr/>
+        </p:nvSpPr>
+        <p:spPr>
+          <a:xfrm>
+            <a:off x="9066047" y="3108960"/>
+            <a:ext cx="2558719" cy="2331720"/>
+          </a:xfrm>
+          <a:prstGeom prst="roundRect">
+            <a:avLst>
+              <a:gd name="adj" fmla="val 5000"/>
+            </a:avLst>
+          </a:prstGeom>
+          <a:solidFill>
+            <a:srgbClr val="F1F5F8"/>
+          </a:solidFill>
+          <a:ln>
+            <a:noFill/>
+          </a:ln>
+          <a:effectLst/>
+        </p:spPr>
+        <p:style>
+          <a:lnRef idx="1">
+            <a:schemeClr val="accent1"/>
+          </a:lnRef>
+          <a:fillRef idx="3">
+            <a:schemeClr val="accent1"/>
+          </a:fillRef>
+          <a:effectRef idx="2">
+            <a:schemeClr val="accent1"/>
+          </a:effectRef>
+          <a:fontRef idx="minor">
+            <a:schemeClr val="lt1"/>
+          </a:fontRef>
+        </p:style>
+        <p:txBody>
+          <a:bodyPr rtlCol="0" anchor="ctr"/>
+          <a:lstStyle/>
+          <a:p>
+            <a:pPr algn="ctr"/>
+            <a:endParaRPr/>
+          </a:p>
+        </p:txBody>
+      </p:sp>
+      <p:sp>
+        <p:nvSpPr>
+          <p:cNvPr id="28" name="Rounded Rectangle 27"/>
+          <p:cNvSpPr/>
+          <p:nvPr/>
+        </p:nvSpPr>
+        <p:spPr>
+          <a:xfrm>
+            <a:off x="9066047" y="3108960"/>
+            <a:ext cx="2558719" cy="475488"/>
+          </a:xfrm>
+          <a:prstGeom prst="roundRect">
+            <a:avLst>
+              <a:gd name="adj" fmla="val 8000"/>
+            </a:avLst>
+          </a:prstGeom>
+          <a:solidFill>
+            <a:srgbClr val="A02B93"/>
+          </a:solidFill>
+          <a:ln>
+            <a:noFill/>
+          </a:ln>
+          <a:effectLst/>
+        </p:spPr>
+        <p:style>
+          <a:lnRef idx="1">
+            <a:schemeClr val="accent1"/>
+          </a:lnRef>
+          <a:fillRef idx="3">
+            <a:schemeClr val="accent1"/>
+          </a:fillRef>
+          <a:effectRef idx="2">
+            <a:schemeClr val="accent1"/>
+          </a:effectRef>
+          <a:fontRef idx="minor">
+            <a:schemeClr val="lt1"/>
+          </a:fontRef>
+        </p:style>
+        <p:txBody>
+          <a:bodyPr rtlCol="0" anchor="ctr"/>
+          <a:lstStyle/>
+          <a:p>
+            <a:pPr algn="ctr"/>
+            <a:endParaRPr/>
+          </a:p>
+        </p:txBody>
+      </p:sp>
+      <p:sp>
+        <p:nvSpPr>
+          <p:cNvPr id="29" name="TextBox 28"/>
+          <p:cNvSpPr txBox="1"/>
+          <p:nvPr/>
+        </p:nvSpPr>
+        <p:spPr>
+          <a:xfrm>
+            <a:off x="9230639" y="3163824"/>
+            <a:ext cx="2284399" cy="365760"/>
+          </a:xfrm>
+          <a:prstGeom prst="rect">
+            <a:avLst/>
+          </a:prstGeom>
+          <a:noFill/>
+        </p:spPr>
+        <p:txBody>
+          <a:bodyPr wrap="square" lIns="0" tIns="0" rIns="0" bIns="0" anchor="ctr">
+            <a:noAutofit/>
+          </a:bodyPr>
+          <a:lstStyle/>
+          <a:p>
+            <a:pPr algn="l">
+              <a:spcBef>
+                <a:spcPts val="0"/>
+              </a:spcBef>
+              <a:spcAft>
+                <a:spcPts val="200"/>
+              </a:spcAft>
+            </a:pPr>
+            <a:r>
+              <a:rPr sz="1400" b="1" i="0">
+                <a:solidFill>
+                  <a:srgbClr val="FFFFFF"/>
+                </a:solidFill>
+                <a:latin typeface="Calibri"/>
+              </a:rPr>
+              <a:t>Sweet spot</a:t>
+            </a:r>
+          </a:p>
+        </p:txBody>
+      </p:sp>
+      <p:sp>
+        <p:nvSpPr>
+          <p:cNvPr id="30" name="TextBox 29"/>
+          <p:cNvSpPr txBox="1"/>
+          <p:nvPr/>
+        </p:nvSpPr>
+        <p:spPr>
+          <a:xfrm>
+            <a:off x="9230639" y="3703320"/>
+            <a:ext cx="2284399" cy="274320"/>
+          </a:xfrm>
+          <a:prstGeom prst="rect">
+            <a:avLst/>
+          </a:prstGeom>
+          <a:noFill/>
+        </p:spPr>
+        <p:txBody>
+          <a:bodyPr wrap="square" lIns="0" tIns="0" rIns="0" bIns="0" anchor="t">
+            <a:noAutofit/>
+          </a:bodyPr>
+          <a:lstStyle/>
+          <a:p>
+            <a:pPr algn="l">
+              <a:spcBef>
+                <a:spcPts val="0"/>
+              </a:spcBef>
+              <a:spcAft>
+                <a:spcPts val="200"/>
+              </a:spcAft>
+            </a:pPr>
+            <a:r>
+              <a:rPr sz="1200" b="1" i="0">
+                <a:solidFill>
+                  <a:srgbClr val="A02B93"/>
+                </a:solidFill>
+                <a:latin typeface="Consolas"/>
+              </a:rPr>
+              <a:t>OLTP + index</a:t>
+            </a:r>
+          </a:p>
+        </p:txBody>
+      </p:sp>
+      <p:sp>
+        <p:nvSpPr>
+          <p:cNvPr id="31" name="TextBox 30"/>
+          <p:cNvSpPr txBox="1"/>
+          <p:nvPr/>
+        </p:nvSpPr>
+        <p:spPr>
+          <a:xfrm>
+            <a:off x="9230639" y="4041648"/>
+            <a:ext cx="2229535" cy="914400"/>
+          </a:xfrm>
+          <a:prstGeom prst="rect">
+            <a:avLst/>
+          </a:prstGeom>
+          <a:noFill/>
+        </p:spPr>
+        <p:txBody>
+          <a:bodyPr wrap="square" lIns="0" tIns="0" rIns="0" bIns="0" anchor="t">
+            <a:noAutofit/>
+          </a:bodyPr>
+          <a:lstStyle/>
+          <a:p>
+            <a:pPr algn="l">
+              <a:spcBef>
+                <a:spcPts val="0"/>
+              </a:spcBef>
+              <a:spcAft>
+                <a:spcPts val="200"/>
+              </a:spcAft>
+            </a:pPr>
+            <a:r>
+              <a:rPr sz="1200" b="0" i="0">
+                <a:solidFill>
+                  <a:srgbClr val="1E2B36"/>
+                </a:solidFill>
+                <a:latin typeface="Calibri"/>
+              </a:rPr>
+              <a:t>Live transactional reads and writes; GiST / SP-GiST index pushdown.</a:t>
+            </a:r>
+          </a:p>
+        </p:txBody>
+      </p:sp>
+      <p:sp>
+        <p:nvSpPr>
+          <p:cNvPr id="32" name="TextBox 31"/>
+          <p:cNvSpPr txBox="1"/>
+          <p:nvPr/>
+        </p:nvSpPr>
+        <p:spPr>
+          <a:xfrm>
+            <a:off x="9230639" y="5074920"/>
+            <a:ext cx="2284399" cy="274320"/>
+          </a:xfrm>
+          <a:prstGeom prst="rect">
+            <a:avLst/>
+          </a:prstGeom>
+          <a:noFill/>
+        </p:spPr>
+        <p:txBody>
+          <a:bodyPr wrap="square" lIns="0" tIns="0" rIns="0" bIns="0" anchor="t">
+            <a:noAutofit/>
+          </a:bodyPr>
+          <a:lstStyle/>
+          <a:p>
+            <a:pPr algn="l">
+              <a:spcBef>
+                <a:spcPts val="0"/>
+              </a:spcBef>
+              <a:spcAft>
+                <a:spcPts val="200"/>
+              </a:spcAft>
+            </a:pPr>
+            <a:r>
+              <a:rPr sz="1200" b="1" i="0">
+                <a:solidFill>
+                  <a:srgbClr val="5B6B78"/>
+                </a:solidFill>
+                <a:latin typeface="Calibri"/>
+              </a:rPr>
+              <a:t>live</a:t>
+            </a:r>
+          </a:p>
+        </p:txBody>
+      </p:sp>
+      <p:sp>
+        <p:nvSpPr>
+          <p:cNvPr id="33" name="TextBox 32"/>
+          <p:cNvSpPr txBox="1"/>
+          <p:nvPr/>
+        </p:nvSpPr>
+        <p:spPr>
+          <a:xfrm>
+            <a:off x="566928" y="5669280"/>
+            <a:ext cx="11057839" cy="640080"/>
+          </a:xfrm>
+          <a:prstGeom prst="rect">
+            <a:avLst/>
+          </a:prstGeom>
+          <a:noFill/>
+        </p:spPr>
+        <p:txBody>
+          <a:bodyPr wrap="square" lIns="0" tIns="0" rIns="0" bIns="0" anchor="t">
+            <a:noAutofit/>
+          </a:bodyPr>
+          <a:lstStyle/>
+          <a:p>
+            <a:pPr algn="ctr">
+              <a:spcBef>
+                <a:spcPts val="0"/>
+              </a:spcBef>
+              <a:spcAft>
+                <a:spcPts val="200"/>
+              </a:spcAft>
+            </a:pPr>
+            <a:r>
+              <a:rPr sz="1200" b="0" i="0">
+                <a:solidFill>
+                  <a:srgbClr val="5B6B78"/>
+                </a:solidFill>
+                <a:latin typeface="Calibri"/>
+              </a:rPr>
+              <a:t>The reference engine: the canonical MEOS named-function SQL served verbatim — MobilityDuck and MobilitySpark return this exact OGC output.</a:t>
+            </a:r>
+          </a:p>
+        </p:txBody>
+      </p:sp>
+      <p:sp>
+        <p:nvSpPr>
+          <p:cNvPr id="34" name="Rectangle 33"/>
+          <p:cNvSpPr/>
+          <p:nvPr/>
+        </p:nvSpPr>
+        <p:spPr>
+          <a:xfrm>
+            <a:off x="566928" y="6455664"/>
+            <a:ext cx="11057839" cy="10972"/>
+          </a:xfrm>
+          <a:prstGeom prst="rect">
+            <a:avLst/>
+          </a:prstGeom>
+          <a:solidFill>
+            <a:srgbClr val="D3DEE6"/>
+          </a:solidFill>
+          <a:ln>
+            <a:noFill/>
+          </a:ln>
+          <a:effectLst/>
+        </p:spPr>
+        <p:style>
+          <a:lnRef idx="1">
+            <a:schemeClr val="accent1"/>
+          </a:lnRef>
+          <a:fillRef idx="3">
+            <a:schemeClr val="accent1"/>
+          </a:fillRef>
+          <a:effectRef idx="2">
+            <a:schemeClr val="accent1"/>
+          </a:effectRef>
+          <a:fontRef idx="minor">
+            <a:schemeClr val="lt1"/>
+          </a:fontRef>
+        </p:style>
+        <p:txBody>
+          <a:bodyPr rtlCol="0" anchor="ctr"/>
+          <a:lstStyle/>
+          <a:p>
+            <a:pPr algn="ctr"/>
+            <a:endParaRPr/>
+          </a:p>
+        </p:txBody>
+      </p:sp>
+      <p:sp>
+        <p:nvSpPr>
+          <p:cNvPr id="35" name="TextBox 34"/>
+          <p:cNvSpPr txBox="1"/>
+          <p:nvPr/>
+        </p:nvSpPr>
+        <p:spPr>
+          <a:xfrm>
+            <a:off x="566928" y="6510528"/>
+            <a:ext cx="7315200" cy="274320"/>
+          </a:xfrm>
+          <a:prstGeom prst="rect">
+            <a:avLst/>
+          </a:prstGeom>
+          <a:noFill/>
+        </p:spPr>
+        <p:txBody>
+          <a:bodyPr wrap="square" lIns="0" tIns="0" rIns="0" bIns="0" anchor="t">
+            <a:noAutofit/>
+          </a:bodyPr>
+          <a:lstStyle/>
+          <a:p>
+            <a:pPr algn="l">
+              <a:spcBef>
+                <a:spcPts val="0"/>
+              </a:spcBef>
+              <a:spcAft>
+                <a:spcPts val="200"/>
+              </a:spcAft>
+            </a:pPr>
+            <a:r>
+              <a:rPr sz="1200" b="0" i="0">
+                <a:solidFill>
+                  <a:srgbClr val="5B6B78"/>
+                </a:solidFill>
+                <a:latin typeface="Calibri"/>
+              </a:rPr>
+              <a:t>MobilityAPI  ·  OGC API – Moving Features</a:t>
+            </a:r>
+          </a:p>
+        </p:txBody>
+      </p:sp>
+      <p:sp>
+        <p:nvSpPr>
+          <p:cNvPr id="36" name="TextBox 35"/>
+          <p:cNvSpPr txBox="1"/>
+          <p:nvPr/>
+        </p:nvSpPr>
+        <p:spPr>
+          <a:xfrm>
+            <a:off x="10911535" y="6510528"/>
+            <a:ext cx="731520" cy="274320"/>
+          </a:xfrm>
+          <a:prstGeom prst="rect">
+            <a:avLst/>
+          </a:prstGeom>
+          <a:noFill/>
+        </p:spPr>
+        <p:txBody>
+          <a:bodyPr wrap="square" lIns="0" tIns="0" rIns="0" bIns="0" anchor="t">
+            <a:noAutofit/>
+          </a:bodyPr>
+          <a:lstStyle/>
+          <a:p>
+            <a:pPr algn="r">
+              <a:spcBef>
+                <a:spcPts val="0"/>
+              </a:spcBef>
+              <a:spcAft>
+                <a:spcPts val="200"/>
+              </a:spcAft>
+            </a:pPr>
+            <a:r>
+              <a:rPr sz="1200" b="0" i="0">
+                <a:solidFill>
+                  <a:srgbClr val="5B6B78"/>
+                </a:solidFill>
+                <a:latin typeface="Calibri"/>
+              </a:rPr>
+              <a:t>26</a:t>
             </a:r>
           </a:p>
         </p:txBody>
@@ -33153,7 +34695,3085 @@
                 </a:solidFill>
                 <a:latin typeface="Calibri"/>
               </a:rPr>
-              <a:t>03</a:t>
+              <a:t>3</a:t>
+            </a:r>
+          </a:p>
+        </p:txBody>
+      </p:sp>
+    </p:spTree>
+  </p:cSld>
+  <p:clrMapOvr>
+    <a:masterClrMapping/>
+  </p:clrMapOvr>
+</p:sld>
+</file>
+
+<file path=ppt/slides/slide30.xml><?xml version="1.0" encoding="utf-8"?>
+<p:sld xmlns:a="http://schemas.openxmlformats.org/drawingml/2006/main" xmlns:p="http://schemas.openxmlformats.org/presentationml/2006/main" xmlns:r="http://schemas.openxmlformats.org/officeDocument/2006/relationships">
+  <p:cSld>
+    <p:spTree>
+      <p:nvGrpSpPr>
+        <p:cNvPr id="1" name=""/>
+        <p:cNvGrpSpPr/>
+        <p:nvPr/>
+      </p:nvGrpSpPr>
+      <p:grpSpPr/>
+      <p:sp>
+        <p:nvSpPr>
+          <p:cNvPr id="2" name="TextBox 1"/>
+          <p:cNvSpPr txBox="1"/>
+          <p:nvPr/>
+        </p:nvSpPr>
+        <p:spPr>
+          <a:xfrm>
+            <a:off x="566928" y="365760"/>
+            <a:ext cx="11057839" cy="274320"/>
+          </a:xfrm>
+          <a:prstGeom prst="rect">
+            <a:avLst/>
+          </a:prstGeom>
+          <a:noFill/>
+        </p:spPr>
+        <p:txBody>
+          <a:bodyPr wrap="square" lIns="0" tIns="0" rIns="0" bIns="0" anchor="t">
+            <a:noAutofit/>
+          </a:bodyPr>
+          <a:lstStyle/>
+          <a:p>
+            <a:pPr algn="l">
+              <a:spcBef>
+                <a:spcPts val="0"/>
+              </a:spcBef>
+              <a:spcAft>
+                <a:spcPts val="200"/>
+              </a:spcAft>
+            </a:pPr>
+            <a:r>
+              <a:rPr sz="1200" b="1" i="0">
+                <a:solidFill>
+                  <a:srgbClr val="156082"/>
+                </a:solidFill>
+                <a:latin typeface="Calibri"/>
+              </a:rPr>
+              <a:t>ENGINE PROFILE</a:t>
+            </a:r>
+          </a:p>
+        </p:txBody>
+      </p:sp>
+      <p:sp>
+        <p:nvSpPr>
+          <p:cNvPr id="3" name="TextBox 2"/>
+          <p:cNvSpPr txBox="1"/>
+          <p:nvPr/>
+        </p:nvSpPr>
+        <p:spPr>
+          <a:xfrm>
+            <a:off x="566928" y="603504"/>
+            <a:ext cx="11057839" cy="777240"/>
+          </a:xfrm>
+          <a:prstGeom prst="rect">
+            <a:avLst/>
+          </a:prstGeom>
+          <a:noFill/>
+        </p:spPr>
+        <p:txBody>
+          <a:bodyPr wrap="square" lIns="0" tIns="0" rIns="0" bIns="0" anchor="t">
+            <a:noAutofit/>
+          </a:bodyPr>
+          <a:lstStyle/>
+          <a:p>
+            <a:pPr algn="l">
+              <a:spcBef>
+                <a:spcPts val="0"/>
+              </a:spcBef>
+              <a:spcAft>
+                <a:spcPts val="200"/>
+              </a:spcAft>
+            </a:pPr>
+            <a:r>
+              <a:rPr sz="3200" b="1" i="0">
+                <a:solidFill>
+                  <a:srgbClr val="0E2841"/>
+                </a:solidFill>
+                <a:latin typeface="Calibri Light"/>
+              </a:rPr>
+              <a:t>MobilityDuck  ·  DuckDB</a:t>
+            </a:r>
+          </a:p>
+        </p:txBody>
+      </p:sp>
+      <p:sp>
+        <p:nvSpPr>
+          <p:cNvPr id="4" name="Rectangle 3"/>
+          <p:cNvSpPr/>
+          <p:nvPr/>
+        </p:nvSpPr>
+        <p:spPr>
+          <a:xfrm>
+            <a:off x="566928" y="1389888"/>
+            <a:ext cx="1554480" cy="45720"/>
+          </a:xfrm>
+          <a:prstGeom prst="rect">
+            <a:avLst/>
+          </a:prstGeom>
+          <a:solidFill>
+            <a:srgbClr val="156082"/>
+          </a:solidFill>
+          <a:ln>
+            <a:noFill/>
+          </a:ln>
+          <a:effectLst/>
+        </p:spPr>
+        <p:style>
+          <a:lnRef idx="1">
+            <a:schemeClr val="accent1"/>
+          </a:lnRef>
+          <a:fillRef idx="3">
+            <a:schemeClr val="accent1"/>
+          </a:fillRef>
+          <a:effectRef idx="2">
+            <a:schemeClr val="accent1"/>
+          </a:effectRef>
+          <a:fontRef idx="minor">
+            <a:schemeClr val="lt1"/>
+          </a:fontRef>
+        </p:style>
+        <p:txBody>
+          <a:bodyPr rtlCol="0" anchor="ctr"/>
+          <a:lstStyle/>
+          <a:p>
+            <a:pPr algn="ctr"/>
+            <a:endParaRPr/>
+          </a:p>
+        </p:txBody>
+      </p:sp>
+      <p:sp>
+        <p:nvSpPr>
+          <p:cNvPr id="5" name="Rounded Rectangle 4"/>
+          <p:cNvSpPr/>
+          <p:nvPr/>
+        </p:nvSpPr>
+        <p:spPr>
+          <a:xfrm>
+            <a:off x="566928" y="1645920"/>
+            <a:ext cx="11057839" cy="868680"/>
+          </a:xfrm>
+          <a:prstGeom prst="roundRect">
+            <a:avLst>
+              <a:gd name="adj" fmla="val 6000"/>
+            </a:avLst>
+          </a:prstGeom>
+          <a:solidFill>
+            <a:srgbClr val="156082"/>
+          </a:solidFill>
+          <a:ln>
+            <a:noFill/>
+          </a:ln>
+          <a:effectLst/>
+        </p:spPr>
+        <p:style>
+          <a:lnRef idx="1">
+            <a:schemeClr val="accent1"/>
+          </a:lnRef>
+          <a:fillRef idx="3">
+            <a:schemeClr val="accent1"/>
+          </a:fillRef>
+          <a:effectRef idx="2">
+            <a:schemeClr val="accent1"/>
+          </a:effectRef>
+          <a:fontRef idx="minor">
+            <a:schemeClr val="lt1"/>
+          </a:fontRef>
+        </p:style>
+        <p:txBody>
+          <a:bodyPr rtlCol="0" anchor="ctr"/>
+          <a:lstStyle/>
+          <a:p>
+            <a:pPr algn="ctr"/>
+            <a:endParaRPr/>
+          </a:p>
+        </p:txBody>
+      </p:sp>
+      <p:sp>
+        <p:nvSpPr>
+          <p:cNvPr id="6" name="TextBox 5"/>
+          <p:cNvSpPr txBox="1"/>
+          <p:nvPr/>
+        </p:nvSpPr>
+        <p:spPr>
+          <a:xfrm>
+            <a:off x="859536" y="1755648"/>
+            <a:ext cx="10472623" cy="320040"/>
+          </a:xfrm>
+          <a:prstGeom prst="rect">
+            <a:avLst/>
+          </a:prstGeom>
+          <a:noFill/>
+        </p:spPr>
+        <p:txBody>
+          <a:bodyPr wrap="square" lIns="0" tIns="0" rIns="0" bIns="0" anchor="t">
+            <a:noAutofit/>
+          </a:bodyPr>
+          <a:lstStyle/>
+          <a:p>
+            <a:pPr algn="l">
+              <a:spcBef>
+                <a:spcPts val="0"/>
+              </a:spcBef>
+              <a:spcAft>
+                <a:spcPts val="200"/>
+              </a:spcAft>
+            </a:pPr>
+            <a:r>
+              <a:rPr sz="1600" b="1" i="0">
+                <a:solidFill>
+                  <a:srgbClr val="FFFFFF"/>
+                </a:solidFill>
+                <a:latin typeface="Calibri"/>
+              </a:rPr>
+              <a:t>Embedded, Parquet-native analytics with no server</a:t>
+            </a:r>
+          </a:p>
+        </p:txBody>
+      </p:sp>
+      <p:sp>
+        <p:nvSpPr>
+          <p:cNvPr id="7" name="TextBox 6"/>
+          <p:cNvSpPr txBox="1"/>
+          <p:nvPr/>
+        </p:nvSpPr>
+        <p:spPr>
+          <a:xfrm>
+            <a:off x="859536" y="2139696"/>
+            <a:ext cx="10472623" cy="274320"/>
+          </a:xfrm>
+          <a:prstGeom prst="rect">
+            <a:avLst/>
+          </a:prstGeom>
+          <a:noFill/>
+        </p:spPr>
+        <p:txBody>
+          <a:bodyPr wrap="square" lIns="0" tIns="0" rIns="0" bIns="0" anchor="t">
+            <a:noAutofit/>
+          </a:bodyPr>
+          <a:lstStyle/>
+          <a:p>
+            <a:pPr algn="l">
+              <a:spcBef>
+                <a:spcPts val="0"/>
+              </a:spcBef>
+              <a:spcAft>
+                <a:spcPts val="200"/>
+              </a:spcAft>
+            </a:pPr>
+            <a:r>
+              <a:rPr sz="1200" b="0" i="0">
+                <a:solidFill>
+                  <a:srgbClr val="CFE2EC"/>
+                </a:solidFill>
+                <a:latin typeface="Calibri"/>
+              </a:rPr>
+              <a:t>Identical OGC output to PostgreSQL over the same canonical SQL</a:t>
+            </a:r>
+          </a:p>
+        </p:txBody>
+      </p:sp>
+      <p:sp>
+        <p:nvSpPr>
+          <p:cNvPr id="8" name="TextBox 7"/>
+          <p:cNvSpPr txBox="1"/>
+          <p:nvPr/>
+        </p:nvSpPr>
+        <p:spPr>
+          <a:xfrm>
+            <a:off x="566928" y="2633472"/>
+            <a:ext cx="11057839" cy="274320"/>
+          </a:xfrm>
+          <a:prstGeom prst="rect">
+            <a:avLst/>
+          </a:prstGeom>
+          <a:noFill/>
+        </p:spPr>
+        <p:txBody>
+          <a:bodyPr wrap="square" lIns="0" tIns="0" rIns="0" bIns="0" anchor="t">
+            <a:noAutofit/>
+          </a:bodyPr>
+          <a:lstStyle/>
+          <a:p>
+            <a:pPr algn="ctr">
+              <a:spcBef>
+                <a:spcPts val="0"/>
+              </a:spcBef>
+              <a:spcAft>
+                <a:spcPts val="200"/>
+              </a:spcAft>
+            </a:pPr>
+            <a:r>
+              <a:rPr sz="1200" b="0" i="0">
+                <a:solidFill>
+                  <a:srgbClr val="5B6B78"/>
+                </a:solidFill>
+                <a:latin typeface="Calibri"/>
+              </a:rPr>
+              <a:t>▼   the engine is a configuration choice — a DSN scheme and a build tag select it</a:t>
+            </a:r>
+          </a:p>
+        </p:txBody>
+      </p:sp>
+      <p:sp>
+        <p:nvSpPr>
+          <p:cNvPr id="9" name="Rounded Rectangle 8"/>
+          <p:cNvSpPr/>
+          <p:nvPr/>
+        </p:nvSpPr>
+        <p:spPr>
+          <a:xfrm>
+            <a:off x="566928" y="3108960"/>
+            <a:ext cx="2558719" cy="2331720"/>
+          </a:xfrm>
+          <a:prstGeom prst="roundRect">
+            <a:avLst>
+              <a:gd name="adj" fmla="val 5000"/>
+            </a:avLst>
+          </a:prstGeom>
+          <a:solidFill>
+            <a:srgbClr val="F1F5F8"/>
+          </a:solidFill>
+          <a:ln>
+            <a:noFill/>
+          </a:ln>
+          <a:effectLst/>
+        </p:spPr>
+        <p:style>
+          <a:lnRef idx="1">
+            <a:schemeClr val="accent1"/>
+          </a:lnRef>
+          <a:fillRef idx="3">
+            <a:schemeClr val="accent1"/>
+          </a:fillRef>
+          <a:effectRef idx="2">
+            <a:schemeClr val="accent1"/>
+          </a:effectRef>
+          <a:fontRef idx="minor">
+            <a:schemeClr val="lt1"/>
+          </a:fontRef>
+        </p:style>
+        <p:txBody>
+          <a:bodyPr rtlCol="0" anchor="ctr"/>
+          <a:lstStyle/>
+          <a:p>
+            <a:pPr algn="ctr"/>
+            <a:endParaRPr/>
+          </a:p>
+        </p:txBody>
+      </p:sp>
+      <p:sp>
+        <p:nvSpPr>
+          <p:cNvPr id="10" name="Rounded Rectangle 9"/>
+          <p:cNvSpPr/>
+          <p:nvPr/>
+        </p:nvSpPr>
+        <p:spPr>
+          <a:xfrm>
+            <a:off x="566928" y="3108960"/>
+            <a:ext cx="2558719" cy="475488"/>
+          </a:xfrm>
+          <a:prstGeom prst="roundRect">
+            <a:avLst>
+              <a:gd name="adj" fmla="val 8000"/>
+            </a:avLst>
+          </a:prstGeom>
+          <a:solidFill>
+            <a:srgbClr val="156082"/>
+          </a:solidFill>
+          <a:ln>
+            <a:noFill/>
+          </a:ln>
+          <a:effectLst/>
+        </p:spPr>
+        <p:style>
+          <a:lnRef idx="1">
+            <a:schemeClr val="accent1"/>
+          </a:lnRef>
+          <a:fillRef idx="3">
+            <a:schemeClr val="accent1"/>
+          </a:fillRef>
+          <a:effectRef idx="2">
+            <a:schemeClr val="accent1"/>
+          </a:effectRef>
+          <a:fontRef idx="minor">
+            <a:schemeClr val="lt1"/>
+          </a:fontRef>
+        </p:style>
+        <p:txBody>
+          <a:bodyPr rtlCol="0" anchor="ctr"/>
+          <a:lstStyle/>
+          <a:p>
+            <a:pPr algn="ctr"/>
+            <a:endParaRPr/>
+          </a:p>
+        </p:txBody>
+      </p:sp>
+      <p:sp>
+        <p:nvSpPr>
+          <p:cNvPr id="11" name="TextBox 10"/>
+          <p:cNvSpPr txBox="1"/>
+          <p:nvPr/>
+        </p:nvSpPr>
+        <p:spPr>
+          <a:xfrm>
+            <a:off x="731520" y="3163824"/>
+            <a:ext cx="2284399" cy="365760"/>
+          </a:xfrm>
+          <a:prstGeom prst="rect">
+            <a:avLst/>
+          </a:prstGeom>
+          <a:noFill/>
+        </p:spPr>
+        <p:txBody>
+          <a:bodyPr wrap="square" lIns="0" tIns="0" rIns="0" bIns="0" anchor="ctr">
+            <a:noAutofit/>
+          </a:bodyPr>
+          <a:lstStyle/>
+          <a:p>
+            <a:pPr algn="l">
+              <a:spcBef>
+                <a:spcPts val="0"/>
+              </a:spcBef>
+              <a:spcAft>
+                <a:spcPts val="200"/>
+              </a:spcAft>
+            </a:pPr>
+            <a:r>
+              <a:rPr sz="1400" b="1" i="0">
+                <a:solidFill>
+                  <a:srgbClr val="FFFFFF"/>
+                </a:solidFill>
+                <a:latin typeface="Calibri"/>
+              </a:rPr>
+              <a:t>Connector</a:t>
+            </a:r>
+          </a:p>
+        </p:txBody>
+      </p:sp>
+      <p:sp>
+        <p:nvSpPr>
+          <p:cNvPr id="12" name="TextBox 11"/>
+          <p:cNvSpPr txBox="1"/>
+          <p:nvPr/>
+        </p:nvSpPr>
+        <p:spPr>
+          <a:xfrm>
+            <a:off x="731520" y="3703320"/>
+            <a:ext cx="2284399" cy="274320"/>
+          </a:xfrm>
+          <a:prstGeom prst="rect">
+            <a:avLst/>
+          </a:prstGeom>
+          <a:noFill/>
+        </p:spPr>
+        <p:txBody>
+          <a:bodyPr wrap="square" lIns="0" tIns="0" rIns="0" bIns="0" anchor="t">
+            <a:noAutofit/>
+          </a:bodyPr>
+          <a:lstStyle/>
+          <a:p>
+            <a:pPr algn="l">
+              <a:spcBef>
+                <a:spcPts val="0"/>
+              </a:spcBef>
+              <a:spcAft>
+                <a:spcPts val="200"/>
+              </a:spcAft>
+            </a:pPr>
+            <a:r>
+              <a:rPr sz="1200" b="1" i="0">
+                <a:solidFill>
+                  <a:srgbClr val="156082"/>
+                </a:solidFill>
+                <a:latin typeface="Consolas"/>
+              </a:rPr>
+              <a:t>go-duckdb</a:t>
+            </a:r>
+          </a:p>
+        </p:txBody>
+      </p:sp>
+      <p:sp>
+        <p:nvSpPr>
+          <p:cNvPr id="13" name="TextBox 12"/>
+          <p:cNvSpPr txBox="1"/>
+          <p:nvPr/>
+        </p:nvSpPr>
+        <p:spPr>
+          <a:xfrm>
+            <a:off x="731520" y="4041648"/>
+            <a:ext cx="2229535" cy="914400"/>
+          </a:xfrm>
+          <a:prstGeom prst="rect">
+            <a:avLst/>
+          </a:prstGeom>
+          <a:noFill/>
+        </p:spPr>
+        <p:txBody>
+          <a:bodyPr wrap="square" lIns="0" tIns="0" rIns="0" bIns="0" anchor="t">
+            <a:noAutofit/>
+          </a:bodyPr>
+          <a:lstStyle/>
+          <a:p>
+            <a:pPr algn="l">
+              <a:spcBef>
+                <a:spcPts val="0"/>
+              </a:spcBef>
+              <a:spcAft>
+                <a:spcPts val="200"/>
+              </a:spcAft>
+            </a:pPr>
+            <a:r>
+              <a:rPr sz="1200" b="0" i="0">
+                <a:solidFill>
+                  <a:srgbClr val="1E2B36"/>
+                </a:solidFill>
+                <a:latin typeface="Calibri"/>
+              </a:rPr>
+              <a:t>Embedded and in-process via database/sql; selected by a duckdb:// DSN.</a:t>
+            </a:r>
+          </a:p>
+        </p:txBody>
+      </p:sp>
+      <p:sp>
+        <p:nvSpPr>
+          <p:cNvPr id="14" name="TextBox 13"/>
+          <p:cNvSpPr txBox="1"/>
+          <p:nvPr/>
+        </p:nvSpPr>
+        <p:spPr>
+          <a:xfrm>
+            <a:off x="731520" y="5074920"/>
+            <a:ext cx="2284399" cy="274320"/>
+          </a:xfrm>
+          <a:prstGeom prst="rect">
+            <a:avLst/>
+          </a:prstGeom>
+          <a:noFill/>
+        </p:spPr>
+        <p:txBody>
+          <a:bodyPr wrap="square" lIns="0" tIns="0" rIns="0" bIns="0" anchor="t">
+            <a:noAutofit/>
+          </a:bodyPr>
+          <a:lstStyle/>
+          <a:p>
+            <a:pPr algn="l">
+              <a:spcBef>
+                <a:spcPts val="0"/>
+              </a:spcBef>
+              <a:spcAft>
+                <a:spcPts val="200"/>
+              </a:spcAft>
+            </a:pPr>
+            <a:r>
+              <a:rPr sz="1200" b="1" i="0">
+                <a:solidFill>
+                  <a:srgbClr val="5B6B78"/>
+                </a:solidFill>
+                <a:latin typeface="Calibri"/>
+              </a:rPr>
+              <a:t>embedded</a:t>
+            </a:r>
+          </a:p>
+        </p:txBody>
+      </p:sp>
+      <p:sp>
+        <p:nvSpPr>
+          <p:cNvPr id="15" name="Rounded Rectangle 14"/>
+          <p:cNvSpPr/>
+          <p:nvPr/>
+        </p:nvSpPr>
+        <p:spPr>
+          <a:xfrm>
+            <a:off x="3399967" y="3108960"/>
+            <a:ext cx="2558719" cy="2331720"/>
+          </a:xfrm>
+          <a:prstGeom prst="roundRect">
+            <a:avLst>
+              <a:gd name="adj" fmla="val 5000"/>
+            </a:avLst>
+          </a:prstGeom>
+          <a:solidFill>
+            <a:srgbClr val="F1F5F8"/>
+          </a:solidFill>
+          <a:ln>
+            <a:noFill/>
+          </a:ln>
+          <a:effectLst/>
+        </p:spPr>
+        <p:style>
+          <a:lnRef idx="1">
+            <a:schemeClr val="accent1"/>
+          </a:lnRef>
+          <a:fillRef idx="3">
+            <a:schemeClr val="accent1"/>
+          </a:fillRef>
+          <a:effectRef idx="2">
+            <a:schemeClr val="accent1"/>
+          </a:effectRef>
+          <a:fontRef idx="minor">
+            <a:schemeClr val="lt1"/>
+          </a:fontRef>
+        </p:style>
+        <p:txBody>
+          <a:bodyPr rtlCol="0" anchor="ctr"/>
+          <a:lstStyle/>
+          <a:p>
+            <a:pPr algn="ctr"/>
+            <a:endParaRPr/>
+          </a:p>
+        </p:txBody>
+      </p:sp>
+      <p:sp>
+        <p:nvSpPr>
+          <p:cNvPr id="16" name="Rounded Rectangle 15"/>
+          <p:cNvSpPr/>
+          <p:nvPr/>
+        </p:nvSpPr>
+        <p:spPr>
+          <a:xfrm>
+            <a:off x="3399967" y="3108960"/>
+            <a:ext cx="2558719" cy="475488"/>
+          </a:xfrm>
+          <a:prstGeom prst="roundRect">
+            <a:avLst>
+              <a:gd name="adj" fmla="val 8000"/>
+            </a:avLst>
+          </a:prstGeom>
+          <a:solidFill>
+            <a:srgbClr val="196B24"/>
+          </a:solidFill>
+          <a:ln>
+            <a:noFill/>
+          </a:ln>
+          <a:effectLst/>
+        </p:spPr>
+        <p:style>
+          <a:lnRef idx="1">
+            <a:schemeClr val="accent1"/>
+          </a:lnRef>
+          <a:fillRef idx="3">
+            <a:schemeClr val="accent1"/>
+          </a:fillRef>
+          <a:effectRef idx="2">
+            <a:schemeClr val="accent1"/>
+          </a:effectRef>
+          <a:fontRef idx="minor">
+            <a:schemeClr val="lt1"/>
+          </a:fontRef>
+        </p:style>
+        <p:txBody>
+          <a:bodyPr rtlCol="0" anchor="ctr"/>
+          <a:lstStyle/>
+          <a:p>
+            <a:pPr algn="ctr"/>
+            <a:endParaRPr/>
+          </a:p>
+        </p:txBody>
+      </p:sp>
+      <p:sp>
+        <p:nvSpPr>
+          <p:cNvPr id="17" name="TextBox 16"/>
+          <p:cNvSpPr txBox="1"/>
+          <p:nvPr/>
+        </p:nvSpPr>
+        <p:spPr>
+          <a:xfrm>
+            <a:off x="3564559" y="3163824"/>
+            <a:ext cx="2284399" cy="365760"/>
+          </a:xfrm>
+          <a:prstGeom prst="rect">
+            <a:avLst/>
+          </a:prstGeom>
+          <a:noFill/>
+        </p:spPr>
+        <p:txBody>
+          <a:bodyPr wrap="square" lIns="0" tIns="0" rIns="0" bIns="0" anchor="ctr">
+            <a:noAutofit/>
+          </a:bodyPr>
+          <a:lstStyle/>
+          <a:p>
+            <a:pPr algn="l">
+              <a:spcBef>
+                <a:spcPts val="0"/>
+              </a:spcBef>
+              <a:spcAft>
+                <a:spcPts val="200"/>
+              </a:spcAft>
+            </a:pPr>
+            <a:r>
+              <a:rPr sz="1400" b="1" i="0">
+                <a:solidFill>
+                  <a:srgbClr val="FFFFFF"/>
+                </a:solidFill>
+                <a:latin typeface="Calibri"/>
+              </a:rPr>
+              <a:t>Build &amp; deploy</a:t>
+            </a:r>
+          </a:p>
+        </p:txBody>
+      </p:sp>
+      <p:sp>
+        <p:nvSpPr>
+          <p:cNvPr id="18" name="TextBox 17"/>
+          <p:cNvSpPr txBox="1"/>
+          <p:nvPr/>
+        </p:nvSpPr>
+        <p:spPr>
+          <a:xfrm>
+            <a:off x="3564559" y="3703320"/>
+            <a:ext cx="2284399" cy="274320"/>
+          </a:xfrm>
+          <a:prstGeom prst="rect">
+            <a:avLst/>
+          </a:prstGeom>
+          <a:noFill/>
+        </p:spPr>
+        <p:txBody>
+          <a:bodyPr wrap="square" lIns="0" tIns="0" rIns="0" bIns="0" anchor="t">
+            <a:noAutofit/>
+          </a:bodyPr>
+          <a:lstStyle/>
+          <a:p>
+            <a:pPr algn="l">
+              <a:spcBef>
+                <a:spcPts val="0"/>
+              </a:spcBef>
+              <a:spcAft>
+                <a:spcPts val="200"/>
+              </a:spcAft>
+            </a:pPr>
+            <a:r>
+              <a:rPr sz="1200" b="1" i="0">
+                <a:solidFill>
+                  <a:srgbClr val="196B24"/>
+                </a:solidFill>
+                <a:latin typeface="Consolas"/>
+              </a:rPr>
+              <a:t>-tags duckdb</a:t>
+            </a:r>
+          </a:p>
+        </p:txBody>
+      </p:sp>
+      <p:sp>
+        <p:nvSpPr>
+          <p:cNvPr id="19" name="TextBox 18"/>
+          <p:cNvSpPr txBox="1"/>
+          <p:nvPr/>
+        </p:nvSpPr>
+        <p:spPr>
+          <a:xfrm>
+            <a:off x="3564559" y="4041648"/>
+            <a:ext cx="2229535" cy="914400"/>
+          </a:xfrm>
+          <a:prstGeom prst="rect">
+            <a:avLst/>
+          </a:prstGeom>
+          <a:noFill/>
+        </p:spPr>
+        <p:txBody>
+          <a:bodyPr wrap="square" lIns="0" tIns="0" rIns="0" bIns="0" anchor="t">
+            <a:noAutofit/>
+          </a:bodyPr>
+          <a:lstStyle/>
+          <a:p>
+            <a:pPr algn="l">
+              <a:spcBef>
+                <a:spcPts val="0"/>
+              </a:spcBef>
+              <a:spcAft>
+                <a:spcPts val="200"/>
+              </a:spcAft>
+            </a:pPr>
+            <a:r>
+              <a:rPr sz="1200" b="0" i="0">
+                <a:solidFill>
+                  <a:srgbClr val="1E2B36"/>
+                </a:solidFill>
+                <a:latin typeface="Calibri"/>
+              </a:rPr>
+              <a:t>MobilityDuck and spatial extensions LOADed per connection.</a:t>
+            </a:r>
+          </a:p>
+        </p:txBody>
+      </p:sp>
+      <p:sp>
+        <p:nvSpPr>
+          <p:cNvPr id="20" name="TextBox 19"/>
+          <p:cNvSpPr txBox="1"/>
+          <p:nvPr/>
+        </p:nvSpPr>
+        <p:spPr>
+          <a:xfrm>
+            <a:off x="3564559" y="5074920"/>
+            <a:ext cx="2284399" cy="274320"/>
+          </a:xfrm>
+          <a:prstGeom prst="rect">
+            <a:avLst/>
+          </a:prstGeom>
+          <a:noFill/>
+        </p:spPr>
+        <p:txBody>
+          <a:bodyPr wrap="square" lIns="0" tIns="0" rIns="0" bIns="0" anchor="t">
+            <a:noAutofit/>
+          </a:bodyPr>
+          <a:lstStyle/>
+          <a:p>
+            <a:pPr algn="l">
+              <a:spcBef>
+                <a:spcPts val="0"/>
+              </a:spcBef>
+              <a:spcAft>
+                <a:spcPts val="200"/>
+              </a:spcAft>
+            </a:pPr>
+            <a:r>
+              <a:rPr sz="1200" b="1" i="0">
+                <a:solidFill>
+                  <a:srgbClr val="5B6B78"/>
+                </a:solidFill>
+                <a:latin typeface="Calibri"/>
+              </a:rPr>
+              <a:t>LOAD</a:t>
+            </a:r>
+          </a:p>
+        </p:txBody>
+      </p:sp>
+      <p:sp>
+        <p:nvSpPr>
+          <p:cNvPr id="21" name="Rounded Rectangle 20"/>
+          <p:cNvSpPr/>
+          <p:nvPr/>
+        </p:nvSpPr>
+        <p:spPr>
+          <a:xfrm>
+            <a:off x="6233007" y="3108960"/>
+            <a:ext cx="2558719" cy="2331720"/>
+          </a:xfrm>
+          <a:prstGeom prst="roundRect">
+            <a:avLst>
+              <a:gd name="adj" fmla="val 5000"/>
+            </a:avLst>
+          </a:prstGeom>
+          <a:solidFill>
+            <a:srgbClr val="F1F5F8"/>
+          </a:solidFill>
+          <a:ln>
+            <a:noFill/>
+          </a:ln>
+          <a:effectLst/>
+        </p:spPr>
+        <p:style>
+          <a:lnRef idx="1">
+            <a:schemeClr val="accent1"/>
+          </a:lnRef>
+          <a:fillRef idx="3">
+            <a:schemeClr val="accent1"/>
+          </a:fillRef>
+          <a:effectRef idx="2">
+            <a:schemeClr val="accent1"/>
+          </a:effectRef>
+          <a:fontRef idx="minor">
+            <a:schemeClr val="lt1"/>
+          </a:fontRef>
+        </p:style>
+        <p:txBody>
+          <a:bodyPr rtlCol="0" anchor="ctr"/>
+          <a:lstStyle/>
+          <a:p>
+            <a:pPr algn="ctr"/>
+            <a:endParaRPr/>
+          </a:p>
+        </p:txBody>
+      </p:sp>
+      <p:sp>
+        <p:nvSpPr>
+          <p:cNvPr id="22" name="Rounded Rectangle 21"/>
+          <p:cNvSpPr/>
+          <p:nvPr/>
+        </p:nvSpPr>
+        <p:spPr>
+          <a:xfrm>
+            <a:off x="6233007" y="3108960"/>
+            <a:ext cx="2558719" cy="475488"/>
+          </a:xfrm>
+          <a:prstGeom prst="roundRect">
+            <a:avLst>
+              <a:gd name="adj" fmla="val 8000"/>
+            </a:avLst>
+          </a:prstGeom>
+          <a:solidFill>
+            <a:srgbClr val="E97132"/>
+          </a:solidFill>
+          <a:ln>
+            <a:noFill/>
+          </a:ln>
+          <a:effectLst/>
+        </p:spPr>
+        <p:style>
+          <a:lnRef idx="1">
+            <a:schemeClr val="accent1"/>
+          </a:lnRef>
+          <a:fillRef idx="3">
+            <a:schemeClr val="accent1"/>
+          </a:fillRef>
+          <a:effectRef idx="2">
+            <a:schemeClr val="accent1"/>
+          </a:effectRef>
+          <a:fontRef idx="minor">
+            <a:schemeClr val="lt1"/>
+          </a:fontRef>
+        </p:style>
+        <p:txBody>
+          <a:bodyPr rtlCol="0" anchor="ctr"/>
+          <a:lstStyle/>
+          <a:p>
+            <a:pPr algn="ctr"/>
+            <a:endParaRPr/>
+          </a:p>
+        </p:txBody>
+      </p:sp>
+      <p:sp>
+        <p:nvSpPr>
+          <p:cNvPr id="23" name="TextBox 22"/>
+          <p:cNvSpPr txBox="1"/>
+          <p:nvPr/>
+        </p:nvSpPr>
+        <p:spPr>
+          <a:xfrm>
+            <a:off x="6397599" y="3163824"/>
+            <a:ext cx="2284399" cy="365760"/>
+          </a:xfrm>
+          <a:prstGeom prst="rect">
+            <a:avLst/>
+          </a:prstGeom>
+          <a:noFill/>
+        </p:spPr>
+        <p:txBody>
+          <a:bodyPr wrap="square" lIns="0" tIns="0" rIns="0" bIns="0" anchor="ctr">
+            <a:noAutofit/>
+          </a:bodyPr>
+          <a:lstStyle/>
+          <a:p>
+            <a:pPr algn="l">
+              <a:spcBef>
+                <a:spcPts val="0"/>
+              </a:spcBef>
+              <a:spcAft>
+                <a:spcPts val="200"/>
+              </a:spcAft>
+            </a:pPr>
+            <a:r>
+              <a:rPr sz="1400" b="1" i="0">
+                <a:solidFill>
+                  <a:srgbClr val="FFFFFF"/>
+                </a:solidFill>
+                <a:latin typeface="Calibri"/>
+              </a:rPr>
+              <a:t>SQL dialect</a:t>
+            </a:r>
+          </a:p>
+        </p:txBody>
+      </p:sp>
+      <p:sp>
+        <p:nvSpPr>
+          <p:cNvPr id="24" name="TextBox 23"/>
+          <p:cNvSpPr txBox="1"/>
+          <p:nvPr/>
+        </p:nvSpPr>
+        <p:spPr>
+          <a:xfrm>
+            <a:off x="6397599" y="3703320"/>
+            <a:ext cx="2284399" cy="274320"/>
+          </a:xfrm>
+          <a:prstGeom prst="rect">
+            <a:avLst/>
+          </a:prstGeom>
+          <a:noFill/>
+        </p:spPr>
+        <p:txBody>
+          <a:bodyPr wrap="square" lIns="0" tIns="0" rIns="0" bIns="0" anchor="t">
+            <a:noAutofit/>
+          </a:bodyPr>
+          <a:lstStyle/>
+          <a:p>
+            <a:pPr algn="l">
+              <a:spcBef>
+                <a:spcPts val="0"/>
+              </a:spcBef>
+              <a:spcAft>
+                <a:spcPts val="200"/>
+              </a:spcAft>
+            </a:pPr>
+            <a:r>
+              <a:rPr sz="1200" b="1" i="0">
+                <a:solidFill>
+                  <a:srgbClr val="E97132"/>
+                </a:solidFill>
+                <a:latin typeface="Consolas"/>
+              </a:rPr>
+              <a:t>identity</a:t>
+            </a:r>
+          </a:p>
+        </p:txBody>
+      </p:sp>
+      <p:sp>
+        <p:nvSpPr>
+          <p:cNvPr id="25" name="TextBox 24"/>
+          <p:cNvSpPr txBox="1"/>
+          <p:nvPr/>
+        </p:nvSpPr>
+        <p:spPr>
+          <a:xfrm>
+            <a:off x="6397599" y="4041648"/>
+            <a:ext cx="2229535" cy="914400"/>
+          </a:xfrm>
+          <a:prstGeom prst="rect">
+            <a:avLst/>
+          </a:prstGeom>
+          <a:noFill/>
+        </p:spPr>
+        <p:txBody>
+          <a:bodyPr wrap="square" lIns="0" tIns="0" rIns="0" bIns="0" anchor="t">
+            <a:noAutofit/>
+          </a:bodyPr>
+          <a:lstStyle/>
+          <a:p>
+            <a:pPr algn="l">
+              <a:spcBef>
+                <a:spcPts val="0"/>
+              </a:spcBef>
+              <a:spcAft>
+                <a:spcPts val="200"/>
+              </a:spcAft>
+            </a:pPr>
+            <a:r>
+              <a:rPr sz="1200" b="0" i="0">
+                <a:solidFill>
+                  <a:srgbClr val="1E2B36"/>
+                </a:solidFill>
+                <a:latin typeface="Calibri"/>
+              </a:rPr>
+              <a:t>Same canonical SQL as PostgreSQL; trajectory GeoJSON cast to text for a uniform scan.</a:t>
+            </a:r>
+          </a:p>
+        </p:txBody>
+      </p:sp>
+      <p:sp>
+        <p:nvSpPr>
+          <p:cNvPr id="26" name="TextBox 25"/>
+          <p:cNvSpPr txBox="1"/>
+          <p:nvPr/>
+        </p:nvSpPr>
+        <p:spPr>
+          <a:xfrm>
+            <a:off x="6397599" y="5074920"/>
+            <a:ext cx="2284399" cy="274320"/>
+          </a:xfrm>
+          <a:prstGeom prst="rect">
+            <a:avLst/>
+          </a:prstGeom>
+          <a:noFill/>
+        </p:spPr>
+        <p:txBody>
+          <a:bodyPr wrap="square" lIns="0" tIns="0" rIns="0" bIns="0" anchor="t">
+            <a:noAutofit/>
+          </a:bodyPr>
+          <a:lstStyle/>
+          <a:p>
+            <a:pPr algn="l">
+              <a:spcBef>
+                <a:spcPts val="0"/>
+              </a:spcBef>
+              <a:spcAft>
+                <a:spcPts val="200"/>
+              </a:spcAft>
+            </a:pPr>
+            <a:r>
+              <a:rPr sz="1200" b="1" i="0">
+                <a:solidFill>
+                  <a:srgbClr val="5B6B78"/>
+                </a:solidFill>
+                <a:latin typeface="Calibri"/>
+              </a:rPr>
+              <a:t>as-is</a:t>
+            </a:r>
+          </a:p>
+        </p:txBody>
+      </p:sp>
+      <p:sp>
+        <p:nvSpPr>
+          <p:cNvPr id="27" name="Rounded Rectangle 26"/>
+          <p:cNvSpPr/>
+          <p:nvPr/>
+        </p:nvSpPr>
+        <p:spPr>
+          <a:xfrm>
+            <a:off x="9066047" y="3108960"/>
+            <a:ext cx="2558719" cy="2331720"/>
+          </a:xfrm>
+          <a:prstGeom prst="roundRect">
+            <a:avLst>
+              <a:gd name="adj" fmla="val 5000"/>
+            </a:avLst>
+          </a:prstGeom>
+          <a:solidFill>
+            <a:srgbClr val="F1F5F8"/>
+          </a:solidFill>
+          <a:ln>
+            <a:noFill/>
+          </a:ln>
+          <a:effectLst/>
+        </p:spPr>
+        <p:style>
+          <a:lnRef idx="1">
+            <a:schemeClr val="accent1"/>
+          </a:lnRef>
+          <a:fillRef idx="3">
+            <a:schemeClr val="accent1"/>
+          </a:fillRef>
+          <a:effectRef idx="2">
+            <a:schemeClr val="accent1"/>
+          </a:effectRef>
+          <a:fontRef idx="minor">
+            <a:schemeClr val="lt1"/>
+          </a:fontRef>
+        </p:style>
+        <p:txBody>
+          <a:bodyPr rtlCol="0" anchor="ctr"/>
+          <a:lstStyle/>
+          <a:p>
+            <a:pPr algn="ctr"/>
+            <a:endParaRPr/>
+          </a:p>
+        </p:txBody>
+      </p:sp>
+      <p:sp>
+        <p:nvSpPr>
+          <p:cNvPr id="28" name="Rounded Rectangle 27"/>
+          <p:cNvSpPr/>
+          <p:nvPr/>
+        </p:nvSpPr>
+        <p:spPr>
+          <a:xfrm>
+            <a:off x="9066047" y="3108960"/>
+            <a:ext cx="2558719" cy="475488"/>
+          </a:xfrm>
+          <a:prstGeom prst="roundRect">
+            <a:avLst>
+              <a:gd name="adj" fmla="val 8000"/>
+            </a:avLst>
+          </a:prstGeom>
+          <a:solidFill>
+            <a:srgbClr val="A02B93"/>
+          </a:solidFill>
+          <a:ln>
+            <a:noFill/>
+          </a:ln>
+          <a:effectLst/>
+        </p:spPr>
+        <p:style>
+          <a:lnRef idx="1">
+            <a:schemeClr val="accent1"/>
+          </a:lnRef>
+          <a:fillRef idx="3">
+            <a:schemeClr val="accent1"/>
+          </a:fillRef>
+          <a:effectRef idx="2">
+            <a:schemeClr val="accent1"/>
+          </a:effectRef>
+          <a:fontRef idx="minor">
+            <a:schemeClr val="lt1"/>
+          </a:fontRef>
+        </p:style>
+        <p:txBody>
+          <a:bodyPr rtlCol="0" anchor="ctr"/>
+          <a:lstStyle/>
+          <a:p>
+            <a:pPr algn="ctr"/>
+            <a:endParaRPr/>
+          </a:p>
+        </p:txBody>
+      </p:sp>
+      <p:sp>
+        <p:nvSpPr>
+          <p:cNvPr id="29" name="TextBox 28"/>
+          <p:cNvSpPr txBox="1"/>
+          <p:nvPr/>
+        </p:nvSpPr>
+        <p:spPr>
+          <a:xfrm>
+            <a:off x="9230639" y="3163824"/>
+            <a:ext cx="2284399" cy="365760"/>
+          </a:xfrm>
+          <a:prstGeom prst="rect">
+            <a:avLst/>
+          </a:prstGeom>
+          <a:noFill/>
+        </p:spPr>
+        <p:txBody>
+          <a:bodyPr wrap="square" lIns="0" tIns="0" rIns="0" bIns="0" anchor="ctr">
+            <a:noAutofit/>
+          </a:bodyPr>
+          <a:lstStyle/>
+          <a:p>
+            <a:pPr algn="l">
+              <a:spcBef>
+                <a:spcPts val="0"/>
+              </a:spcBef>
+              <a:spcAft>
+                <a:spcPts val="200"/>
+              </a:spcAft>
+            </a:pPr>
+            <a:r>
+              <a:rPr sz="1400" b="1" i="0">
+                <a:solidFill>
+                  <a:srgbClr val="FFFFFF"/>
+                </a:solidFill>
+                <a:latin typeface="Calibri"/>
+              </a:rPr>
+              <a:t>Sweet spot</a:t>
+            </a:r>
+          </a:p>
+        </p:txBody>
+      </p:sp>
+      <p:sp>
+        <p:nvSpPr>
+          <p:cNvPr id="30" name="TextBox 29"/>
+          <p:cNvSpPr txBox="1"/>
+          <p:nvPr/>
+        </p:nvSpPr>
+        <p:spPr>
+          <a:xfrm>
+            <a:off x="9230639" y="3703320"/>
+            <a:ext cx="2284399" cy="274320"/>
+          </a:xfrm>
+          <a:prstGeom prst="rect">
+            <a:avLst/>
+          </a:prstGeom>
+          <a:noFill/>
+        </p:spPr>
+        <p:txBody>
+          <a:bodyPr wrap="square" lIns="0" tIns="0" rIns="0" bIns="0" anchor="t">
+            <a:noAutofit/>
+          </a:bodyPr>
+          <a:lstStyle/>
+          <a:p>
+            <a:pPr algn="l">
+              <a:spcBef>
+                <a:spcPts val="0"/>
+              </a:spcBef>
+              <a:spcAft>
+                <a:spcPts val="200"/>
+              </a:spcAft>
+            </a:pPr>
+            <a:r>
+              <a:rPr sz="1200" b="1" i="0">
+                <a:solidFill>
+                  <a:srgbClr val="A02B93"/>
+                </a:solidFill>
+                <a:latin typeface="Consolas"/>
+              </a:rPr>
+              <a:t>lakehouse</a:t>
+            </a:r>
+          </a:p>
+        </p:txBody>
+      </p:sp>
+      <p:sp>
+        <p:nvSpPr>
+          <p:cNvPr id="31" name="TextBox 30"/>
+          <p:cNvSpPr txBox="1"/>
+          <p:nvPr/>
+        </p:nvSpPr>
+        <p:spPr>
+          <a:xfrm>
+            <a:off x="9230639" y="4041648"/>
+            <a:ext cx="2229535" cy="914400"/>
+          </a:xfrm>
+          <a:prstGeom prst="rect">
+            <a:avLst/>
+          </a:prstGeom>
+          <a:noFill/>
+        </p:spPr>
+        <p:txBody>
+          <a:bodyPr wrap="square" lIns="0" tIns="0" rIns="0" bIns="0" anchor="t">
+            <a:noAutofit/>
+          </a:bodyPr>
+          <a:lstStyle/>
+          <a:p>
+            <a:pPr algn="l">
+              <a:spcBef>
+                <a:spcPts val="0"/>
+              </a:spcBef>
+              <a:spcAft>
+                <a:spcPts val="200"/>
+              </a:spcAft>
+            </a:pPr>
+            <a:r>
+              <a:rPr sz="1200" b="0" i="0">
+                <a:solidFill>
+                  <a:srgbClr val="1E2B36"/>
+                </a:solidFill>
+                <a:latin typeface="Calibri"/>
+              </a:rPr>
+              <a:t>Parquet-native analytical queries over local files; no database server.</a:t>
+            </a:r>
+          </a:p>
+        </p:txBody>
+      </p:sp>
+      <p:sp>
+        <p:nvSpPr>
+          <p:cNvPr id="32" name="TextBox 31"/>
+          <p:cNvSpPr txBox="1"/>
+          <p:nvPr/>
+        </p:nvSpPr>
+        <p:spPr>
+          <a:xfrm>
+            <a:off x="9230639" y="5074920"/>
+            <a:ext cx="2284399" cy="274320"/>
+          </a:xfrm>
+          <a:prstGeom prst="rect">
+            <a:avLst/>
+          </a:prstGeom>
+          <a:noFill/>
+        </p:spPr>
+        <p:txBody>
+          <a:bodyPr wrap="square" lIns="0" tIns="0" rIns="0" bIns="0" anchor="t">
+            <a:noAutofit/>
+          </a:bodyPr>
+          <a:lstStyle/>
+          <a:p>
+            <a:pPr algn="l">
+              <a:spcBef>
+                <a:spcPts val="0"/>
+              </a:spcBef>
+              <a:spcAft>
+                <a:spcPts val="200"/>
+              </a:spcAft>
+            </a:pPr>
+            <a:r>
+              <a:rPr sz="1200" b="1" i="0">
+                <a:solidFill>
+                  <a:srgbClr val="5B6B78"/>
+                </a:solidFill>
+                <a:latin typeface="Calibri"/>
+              </a:rPr>
+              <a:t>Parquet</a:t>
+            </a:r>
+          </a:p>
+        </p:txBody>
+      </p:sp>
+      <p:sp>
+        <p:nvSpPr>
+          <p:cNvPr id="33" name="TextBox 32"/>
+          <p:cNvSpPr txBox="1"/>
+          <p:nvPr/>
+        </p:nvSpPr>
+        <p:spPr>
+          <a:xfrm>
+            <a:off x="566928" y="5669280"/>
+            <a:ext cx="11057839" cy="640080"/>
+          </a:xfrm>
+          <a:prstGeom prst="rect">
+            <a:avLst/>
+          </a:prstGeom>
+          <a:noFill/>
+        </p:spPr>
+        <p:txBody>
+          <a:bodyPr wrap="square" lIns="0" tIns="0" rIns="0" bIns="0" anchor="t">
+            <a:noAutofit/>
+          </a:bodyPr>
+          <a:lstStyle/>
+          <a:p>
+            <a:pPr algn="ctr">
+              <a:spcBef>
+                <a:spcPts val="0"/>
+              </a:spcBef>
+              <a:spcAft>
+                <a:spcPts val="200"/>
+              </a:spcAft>
+            </a:pPr>
+            <a:r>
+              <a:rPr sz="1200" b="0" i="0">
+                <a:solidFill>
+                  <a:srgbClr val="5B6B78"/>
+                </a:solidFill>
+                <a:latin typeface="Calibri"/>
+              </a:rPr>
+              <a:t>Same thin tier, same canonical SQL, same Go response assembly — only the connector changes; identical OGC output to PostgreSQL.</a:t>
+            </a:r>
+          </a:p>
+        </p:txBody>
+      </p:sp>
+      <p:sp>
+        <p:nvSpPr>
+          <p:cNvPr id="34" name="Rectangle 33"/>
+          <p:cNvSpPr/>
+          <p:nvPr/>
+        </p:nvSpPr>
+        <p:spPr>
+          <a:xfrm>
+            <a:off x="566928" y="6455664"/>
+            <a:ext cx="11057839" cy="10972"/>
+          </a:xfrm>
+          <a:prstGeom prst="rect">
+            <a:avLst/>
+          </a:prstGeom>
+          <a:solidFill>
+            <a:srgbClr val="D3DEE6"/>
+          </a:solidFill>
+          <a:ln>
+            <a:noFill/>
+          </a:ln>
+          <a:effectLst/>
+        </p:spPr>
+        <p:style>
+          <a:lnRef idx="1">
+            <a:schemeClr val="accent1"/>
+          </a:lnRef>
+          <a:fillRef idx="3">
+            <a:schemeClr val="accent1"/>
+          </a:fillRef>
+          <a:effectRef idx="2">
+            <a:schemeClr val="accent1"/>
+          </a:effectRef>
+          <a:fontRef idx="minor">
+            <a:schemeClr val="lt1"/>
+          </a:fontRef>
+        </p:style>
+        <p:txBody>
+          <a:bodyPr rtlCol="0" anchor="ctr"/>
+          <a:lstStyle/>
+          <a:p>
+            <a:pPr algn="ctr"/>
+            <a:endParaRPr/>
+          </a:p>
+        </p:txBody>
+      </p:sp>
+      <p:sp>
+        <p:nvSpPr>
+          <p:cNvPr id="35" name="TextBox 34"/>
+          <p:cNvSpPr txBox="1"/>
+          <p:nvPr/>
+        </p:nvSpPr>
+        <p:spPr>
+          <a:xfrm>
+            <a:off x="566928" y="6510528"/>
+            <a:ext cx="7315200" cy="274320"/>
+          </a:xfrm>
+          <a:prstGeom prst="rect">
+            <a:avLst/>
+          </a:prstGeom>
+          <a:noFill/>
+        </p:spPr>
+        <p:txBody>
+          <a:bodyPr wrap="square" lIns="0" tIns="0" rIns="0" bIns="0" anchor="t">
+            <a:noAutofit/>
+          </a:bodyPr>
+          <a:lstStyle/>
+          <a:p>
+            <a:pPr algn="l">
+              <a:spcBef>
+                <a:spcPts val="0"/>
+              </a:spcBef>
+              <a:spcAft>
+                <a:spcPts val="200"/>
+              </a:spcAft>
+            </a:pPr>
+            <a:r>
+              <a:rPr sz="1200" b="0" i="0">
+                <a:solidFill>
+                  <a:srgbClr val="5B6B78"/>
+                </a:solidFill>
+                <a:latin typeface="Calibri"/>
+              </a:rPr>
+              <a:t>MobilityAPI  ·  OGC API – Moving Features</a:t>
+            </a:r>
+          </a:p>
+        </p:txBody>
+      </p:sp>
+      <p:sp>
+        <p:nvSpPr>
+          <p:cNvPr id="36" name="TextBox 35"/>
+          <p:cNvSpPr txBox="1"/>
+          <p:nvPr/>
+        </p:nvSpPr>
+        <p:spPr>
+          <a:xfrm>
+            <a:off x="10911535" y="6510528"/>
+            <a:ext cx="731520" cy="274320"/>
+          </a:xfrm>
+          <a:prstGeom prst="rect">
+            <a:avLst/>
+          </a:prstGeom>
+          <a:noFill/>
+        </p:spPr>
+        <p:txBody>
+          <a:bodyPr wrap="square" lIns="0" tIns="0" rIns="0" bIns="0" anchor="t">
+            <a:noAutofit/>
+          </a:bodyPr>
+          <a:lstStyle/>
+          <a:p>
+            <a:pPr algn="r">
+              <a:spcBef>
+                <a:spcPts val="0"/>
+              </a:spcBef>
+              <a:spcAft>
+                <a:spcPts val="200"/>
+              </a:spcAft>
+            </a:pPr>
+            <a:r>
+              <a:rPr sz="1200" b="0" i="0">
+                <a:solidFill>
+                  <a:srgbClr val="5B6B78"/>
+                </a:solidFill>
+                <a:latin typeface="Calibri"/>
+              </a:rPr>
+              <a:t>27</a:t>
+            </a:r>
+          </a:p>
+        </p:txBody>
+      </p:sp>
+    </p:spTree>
+  </p:cSld>
+  <p:clrMapOvr>
+    <a:masterClrMapping/>
+  </p:clrMapOvr>
+</p:sld>
+</file>
+
+<file path=ppt/slides/slide31.xml><?xml version="1.0" encoding="utf-8"?>
+<p:sld xmlns:a="http://schemas.openxmlformats.org/drawingml/2006/main" xmlns:p="http://schemas.openxmlformats.org/presentationml/2006/main" xmlns:r="http://schemas.openxmlformats.org/officeDocument/2006/relationships">
+  <p:cSld>
+    <p:spTree>
+      <p:nvGrpSpPr>
+        <p:cNvPr id="1" name=""/>
+        <p:cNvGrpSpPr/>
+        <p:nvPr/>
+      </p:nvGrpSpPr>
+      <p:grpSpPr/>
+      <p:sp>
+        <p:nvSpPr>
+          <p:cNvPr id="2" name="TextBox 1"/>
+          <p:cNvSpPr txBox="1"/>
+          <p:nvPr/>
+        </p:nvSpPr>
+        <p:spPr>
+          <a:xfrm>
+            <a:off x="566928" y="365760"/>
+            <a:ext cx="11057839" cy="274320"/>
+          </a:xfrm>
+          <a:prstGeom prst="rect">
+            <a:avLst/>
+          </a:prstGeom>
+          <a:noFill/>
+        </p:spPr>
+        <p:txBody>
+          <a:bodyPr wrap="square" lIns="0" tIns="0" rIns="0" bIns="0" anchor="t">
+            <a:noAutofit/>
+          </a:bodyPr>
+          <a:lstStyle/>
+          <a:p>
+            <a:pPr algn="l">
+              <a:spcBef>
+                <a:spcPts val="0"/>
+              </a:spcBef>
+              <a:spcAft>
+                <a:spcPts val="200"/>
+              </a:spcAft>
+            </a:pPr>
+            <a:r>
+              <a:rPr sz="1200" b="1" i="0">
+                <a:solidFill>
+                  <a:srgbClr val="156082"/>
+                </a:solidFill>
+                <a:latin typeface="Calibri"/>
+              </a:rPr>
+              <a:t>ENGINE PROFILE</a:t>
+            </a:r>
+          </a:p>
+        </p:txBody>
+      </p:sp>
+      <p:sp>
+        <p:nvSpPr>
+          <p:cNvPr id="3" name="TextBox 2"/>
+          <p:cNvSpPr txBox="1"/>
+          <p:nvPr/>
+        </p:nvSpPr>
+        <p:spPr>
+          <a:xfrm>
+            <a:off x="566928" y="603504"/>
+            <a:ext cx="11057839" cy="777240"/>
+          </a:xfrm>
+          <a:prstGeom prst="rect">
+            <a:avLst/>
+          </a:prstGeom>
+          <a:noFill/>
+        </p:spPr>
+        <p:txBody>
+          <a:bodyPr wrap="square" lIns="0" tIns="0" rIns="0" bIns="0" anchor="t">
+            <a:noAutofit/>
+          </a:bodyPr>
+          <a:lstStyle/>
+          <a:p>
+            <a:pPr algn="l">
+              <a:spcBef>
+                <a:spcPts val="0"/>
+              </a:spcBef>
+              <a:spcAft>
+                <a:spcPts val="200"/>
+              </a:spcAft>
+            </a:pPr>
+            <a:r>
+              <a:rPr sz="3200" b="1" i="0">
+                <a:solidFill>
+                  <a:srgbClr val="0E2841"/>
+                </a:solidFill>
+                <a:latin typeface="Calibri Light"/>
+              </a:rPr>
+              <a:t>MobilitySpark  ·  Apache Spark</a:t>
+            </a:r>
+          </a:p>
+        </p:txBody>
+      </p:sp>
+      <p:sp>
+        <p:nvSpPr>
+          <p:cNvPr id="4" name="Rectangle 3"/>
+          <p:cNvSpPr/>
+          <p:nvPr/>
+        </p:nvSpPr>
+        <p:spPr>
+          <a:xfrm>
+            <a:off x="566928" y="1389888"/>
+            <a:ext cx="1554480" cy="45720"/>
+          </a:xfrm>
+          <a:prstGeom prst="rect">
+            <a:avLst/>
+          </a:prstGeom>
+          <a:solidFill>
+            <a:srgbClr val="156082"/>
+          </a:solidFill>
+          <a:ln>
+            <a:noFill/>
+          </a:ln>
+          <a:effectLst/>
+        </p:spPr>
+        <p:style>
+          <a:lnRef idx="1">
+            <a:schemeClr val="accent1"/>
+          </a:lnRef>
+          <a:fillRef idx="3">
+            <a:schemeClr val="accent1"/>
+          </a:fillRef>
+          <a:effectRef idx="2">
+            <a:schemeClr val="accent1"/>
+          </a:effectRef>
+          <a:fontRef idx="minor">
+            <a:schemeClr val="lt1"/>
+          </a:fontRef>
+        </p:style>
+        <p:txBody>
+          <a:bodyPr rtlCol="0" anchor="ctr"/>
+          <a:lstStyle/>
+          <a:p>
+            <a:pPr algn="ctr"/>
+            <a:endParaRPr/>
+          </a:p>
+        </p:txBody>
+      </p:sp>
+      <p:sp>
+        <p:nvSpPr>
+          <p:cNvPr id="5" name="Rounded Rectangle 4"/>
+          <p:cNvSpPr/>
+          <p:nvPr/>
+        </p:nvSpPr>
+        <p:spPr>
+          <a:xfrm>
+            <a:off x="566928" y="1645920"/>
+            <a:ext cx="11057839" cy="868680"/>
+          </a:xfrm>
+          <a:prstGeom prst="roundRect">
+            <a:avLst>
+              <a:gd name="adj" fmla="val 6000"/>
+            </a:avLst>
+          </a:prstGeom>
+          <a:solidFill>
+            <a:srgbClr val="156082"/>
+          </a:solidFill>
+          <a:ln>
+            <a:noFill/>
+          </a:ln>
+          <a:effectLst/>
+        </p:spPr>
+        <p:style>
+          <a:lnRef idx="1">
+            <a:schemeClr val="accent1"/>
+          </a:lnRef>
+          <a:fillRef idx="3">
+            <a:schemeClr val="accent1"/>
+          </a:fillRef>
+          <a:effectRef idx="2">
+            <a:schemeClr val="accent1"/>
+          </a:effectRef>
+          <a:fontRef idx="minor">
+            <a:schemeClr val="lt1"/>
+          </a:fontRef>
+        </p:style>
+        <p:txBody>
+          <a:bodyPr rtlCol="0" anchor="ctr"/>
+          <a:lstStyle/>
+          <a:p>
+            <a:pPr algn="ctr"/>
+            <a:endParaRPr/>
+          </a:p>
+        </p:txBody>
+      </p:sp>
+      <p:sp>
+        <p:nvSpPr>
+          <p:cNvPr id="6" name="TextBox 5"/>
+          <p:cNvSpPr txBox="1"/>
+          <p:nvPr/>
+        </p:nvSpPr>
+        <p:spPr>
+          <a:xfrm>
+            <a:off x="859536" y="1755648"/>
+            <a:ext cx="10472623" cy="320040"/>
+          </a:xfrm>
+          <a:prstGeom prst="rect">
+            <a:avLst/>
+          </a:prstGeom>
+          <a:noFill/>
+        </p:spPr>
+        <p:txBody>
+          <a:bodyPr wrap="square" lIns="0" tIns="0" rIns="0" bIns="0" anchor="t">
+            <a:noAutofit/>
+          </a:bodyPr>
+          <a:lstStyle/>
+          <a:p>
+            <a:pPr algn="l">
+              <a:spcBef>
+                <a:spcPts val="0"/>
+              </a:spcBef>
+              <a:spcAft>
+                <a:spcPts val="200"/>
+              </a:spcAft>
+            </a:pPr>
+            <a:r>
+              <a:rPr sz="1600" b="1" i="0">
+                <a:solidFill>
+                  <a:srgbClr val="FFFFFF"/>
+                </a:solidFill>
+                <a:latin typeface="Calibri"/>
+              </a:rPr>
+              <a:t>Distributed batch over very large movement histories</a:t>
+            </a:r>
+          </a:p>
+        </p:txBody>
+      </p:sp>
+      <p:sp>
+        <p:nvSpPr>
+          <p:cNvPr id="7" name="TextBox 6"/>
+          <p:cNvSpPr txBox="1"/>
+          <p:nvPr/>
+        </p:nvSpPr>
+        <p:spPr>
+          <a:xfrm>
+            <a:off x="859536" y="2139696"/>
+            <a:ext cx="10472623" cy="274320"/>
+          </a:xfrm>
+          <a:prstGeom prst="rect">
+            <a:avLst/>
+          </a:prstGeom>
+          <a:noFill/>
+        </p:spPr>
+        <p:txBody>
+          <a:bodyPr wrap="square" lIns="0" tIns="0" rIns="0" bIns="0" anchor="t">
+            <a:noAutofit/>
+          </a:bodyPr>
+          <a:lstStyle/>
+          <a:p>
+            <a:pPr algn="l">
+              <a:spcBef>
+                <a:spcPts val="0"/>
+              </a:spcBef>
+              <a:spcAft>
+                <a:spcPts val="200"/>
+              </a:spcAft>
+            </a:pPr>
+            <a:r>
+              <a:rPr sz="1200" b="0" i="0">
+                <a:solidFill>
+                  <a:srgbClr val="CFE2EC"/>
+                </a:solidFill>
+                <a:latin typeface="Calibri"/>
+              </a:rPr>
+              <a:t>The same canonical SQL as PostgreSQL and DuckDB, over Spark Connect</a:t>
+            </a:r>
+          </a:p>
+        </p:txBody>
+      </p:sp>
+      <p:sp>
+        <p:nvSpPr>
+          <p:cNvPr id="8" name="TextBox 7"/>
+          <p:cNvSpPr txBox="1"/>
+          <p:nvPr/>
+        </p:nvSpPr>
+        <p:spPr>
+          <a:xfrm>
+            <a:off x="566928" y="2633472"/>
+            <a:ext cx="11057839" cy="274320"/>
+          </a:xfrm>
+          <a:prstGeom prst="rect">
+            <a:avLst/>
+          </a:prstGeom>
+          <a:noFill/>
+        </p:spPr>
+        <p:txBody>
+          <a:bodyPr wrap="square" lIns="0" tIns="0" rIns="0" bIns="0" anchor="t">
+            <a:noAutofit/>
+          </a:bodyPr>
+          <a:lstStyle/>
+          <a:p>
+            <a:pPr algn="ctr">
+              <a:spcBef>
+                <a:spcPts val="0"/>
+              </a:spcBef>
+              <a:spcAft>
+                <a:spcPts val="200"/>
+              </a:spcAft>
+            </a:pPr>
+            <a:r>
+              <a:rPr sz="1200" b="0" i="0">
+                <a:solidFill>
+                  <a:srgbClr val="5B6B78"/>
+                </a:solidFill>
+                <a:latin typeface="Calibri"/>
+              </a:rPr>
+              <a:t>▼   the engine is a configuration choice — a DSN scheme and a build tag select it</a:t>
+            </a:r>
+          </a:p>
+        </p:txBody>
+      </p:sp>
+      <p:sp>
+        <p:nvSpPr>
+          <p:cNvPr id="9" name="Rounded Rectangle 8"/>
+          <p:cNvSpPr/>
+          <p:nvPr/>
+        </p:nvSpPr>
+        <p:spPr>
+          <a:xfrm>
+            <a:off x="566928" y="3108960"/>
+            <a:ext cx="2558719" cy="2331720"/>
+          </a:xfrm>
+          <a:prstGeom prst="roundRect">
+            <a:avLst>
+              <a:gd name="adj" fmla="val 5000"/>
+            </a:avLst>
+          </a:prstGeom>
+          <a:solidFill>
+            <a:srgbClr val="F1F5F8"/>
+          </a:solidFill>
+          <a:ln>
+            <a:noFill/>
+          </a:ln>
+          <a:effectLst/>
+        </p:spPr>
+        <p:style>
+          <a:lnRef idx="1">
+            <a:schemeClr val="accent1"/>
+          </a:lnRef>
+          <a:fillRef idx="3">
+            <a:schemeClr val="accent1"/>
+          </a:fillRef>
+          <a:effectRef idx="2">
+            <a:schemeClr val="accent1"/>
+          </a:effectRef>
+          <a:fontRef idx="minor">
+            <a:schemeClr val="lt1"/>
+          </a:fontRef>
+        </p:style>
+        <p:txBody>
+          <a:bodyPr rtlCol="0" anchor="ctr"/>
+          <a:lstStyle/>
+          <a:p>
+            <a:pPr algn="ctr"/>
+            <a:endParaRPr/>
+          </a:p>
+        </p:txBody>
+      </p:sp>
+      <p:sp>
+        <p:nvSpPr>
+          <p:cNvPr id="10" name="Rounded Rectangle 9"/>
+          <p:cNvSpPr/>
+          <p:nvPr/>
+        </p:nvSpPr>
+        <p:spPr>
+          <a:xfrm>
+            <a:off x="566928" y="3108960"/>
+            <a:ext cx="2558719" cy="475488"/>
+          </a:xfrm>
+          <a:prstGeom prst="roundRect">
+            <a:avLst>
+              <a:gd name="adj" fmla="val 8000"/>
+            </a:avLst>
+          </a:prstGeom>
+          <a:solidFill>
+            <a:srgbClr val="156082"/>
+          </a:solidFill>
+          <a:ln>
+            <a:noFill/>
+          </a:ln>
+          <a:effectLst/>
+        </p:spPr>
+        <p:style>
+          <a:lnRef idx="1">
+            <a:schemeClr val="accent1"/>
+          </a:lnRef>
+          <a:fillRef idx="3">
+            <a:schemeClr val="accent1"/>
+          </a:fillRef>
+          <a:effectRef idx="2">
+            <a:schemeClr val="accent1"/>
+          </a:effectRef>
+          <a:fontRef idx="minor">
+            <a:schemeClr val="lt1"/>
+          </a:fontRef>
+        </p:style>
+        <p:txBody>
+          <a:bodyPr rtlCol="0" anchor="ctr"/>
+          <a:lstStyle/>
+          <a:p>
+            <a:pPr algn="ctr"/>
+            <a:endParaRPr/>
+          </a:p>
+        </p:txBody>
+      </p:sp>
+      <p:sp>
+        <p:nvSpPr>
+          <p:cNvPr id="11" name="TextBox 10"/>
+          <p:cNvSpPr txBox="1"/>
+          <p:nvPr/>
+        </p:nvSpPr>
+        <p:spPr>
+          <a:xfrm>
+            <a:off x="731520" y="3163824"/>
+            <a:ext cx="2284399" cy="365760"/>
+          </a:xfrm>
+          <a:prstGeom prst="rect">
+            <a:avLst/>
+          </a:prstGeom>
+          <a:noFill/>
+        </p:spPr>
+        <p:txBody>
+          <a:bodyPr wrap="square" lIns="0" tIns="0" rIns="0" bIns="0" anchor="ctr">
+            <a:noAutofit/>
+          </a:bodyPr>
+          <a:lstStyle/>
+          <a:p>
+            <a:pPr algn="l">
+              <a:spcBef>
+                <a:spcPts val="0"/>
+              </a:spcBef>
+              <a:spcAft>
+                <a:spcPts val="200"/>
+              </a:spcAft>
+            </a:pPr>
+            <a:r>
+              <a:rPr sz="1400" b="1" i="0">
+                <a:solidFill>
+                  <a:srgbClr val="FFFFFF"/>
+                </a:solidFill>
+                <a:latin typeface="Calibri"/>
+              </a:rPr>
+              <a:t>Connector</a:t>
+            </a:r>
+          </a:p>
+        </p:txBody>
+      </p:sp>
+      <p:sp>
+        <p:nvSpPr>
+          <p:cNvPr id="12" name="TextBox 11"/>
+          <p:cNvSpPr txBox="1"/>
+          <p:nvPr/>
+        </p:nvSpPr>
+        <p:spPr>
+          <a:xfrm>
+            <a:off x="731520" y="3703320"/>
+            <a:ext cx="2284399" cy="274320"/>
+          </a:xfrm>
+          <a:prstGeom prst="rect">
+            <a:avLst/>
+          </a:prstGeom>
+          <a:noFill/>
+        </p:spPr>
+        <p:txBody>
+          <a:bodyPr wrap="square" lIns="0" tIns="0" rIns="0" bIns="0" anchor="t">
+            <a:noAutofit/>
+          </a:bodyPr>
+          <a:lstStyle/>
+          <a:p>
+            <a:pPr algn="l">
+              <a:spcBef>
+                <a:spcPts val="0"/>
+              </a:spcBef>
+              <a:spcAft>
+                <a:spcPts val="200"/>
+              </a:spcAft>
+            </a:pPr>
+            <a:r>
+              <a:rPr sz="1200" b="1" i="0">
+                <a:solidFill>
+                  <a:srgbClr val="156082"/>
+                </a:solidFill>
+                <a:latin typeface="Consolas"/>
+              </a:rPr>
+              <a:t>Spark Connect</a:t>
+            </a:r>
+          </a:p>
+        </p:txBody>
+      </p:sp>
+      <p:sp>
+        <p:nvSpPr>
+          <p:cNvPr id="13" name="TextBox 12"/>
+          <p:cNvSpPr txBox="1"/>
+          <p:nvPr/>
+        </p:nvSpPr>
+        <p:spPr>
+          <a:xfrm>
+            <a:off x="731520" y="4041648"/>
+            <a:ext cx="2229535" cy="914400"/>
+          </a:xfrm>
+          <a:prstGeom prst="rect">
+            <a:avLst/>
+          </a:prstGeom>
+          <a:noFill/>
+        </p:spPr>
+        <p:txBody>
+          <a:bodyPr wrap="square" lIns="0" tIns="0" rIns="0" bIns="0" anchor="t">
+            <a:noAutofit/>
+          </a:bodyPr>
+          <a:lstStyle/>
+          <a:p>
+            <a:pPr algn="l">
+              <a:spcBef>
+                <a:spcPts val="0"/>
+              </a:spcBef>
+              <a:spcAft>
+                <a:spcPts val="200"/>
+              </a:spcAft>
+            </a:pPr>
+            <a:r>
+              <a:rPr sz="1200" b="0" i="0">
+                <a:solidFill>
+                  <a:srgbClr val="1E2B36"/>
+                </a:solidFill>
+                <a:latin typeface="Calibri"/>
+              </a:rPr>
+              <a:t>Selected by a spark:// DSN; compiles against spark-connect-go.</a:t>
+            </a:r>
+          </a:p>
+        </p:txBody>
+      </p:sp>
+      <p:sp>
+        <p:nvSpPr>
+          <p:cNvPr id="14" name="TextBox 13"/>
+          <p:cNvSpPr txBox="1"/>
+          <p:nvPr/>
+        </p:nvSpPr>
+        <p:spPr>
+          <a:xfrm>
+            <a:off x="731520" y="5074920"/>
+            <a:ext cx="2284399" cy="274320"/>
+          </a:xfrm>
+          <a:prstGeom prst="rect">
+            <a:avLst/>
+          </a:prstGeom>
+          <a:noFill/>
+        </p:spPr>
+        <p:txBody>
+          <a:bodyPr wrap="square" lIns="0" tIns="0" rIns="0" bIns="0" anchor="t">
+            <a:noAutofit/>
+          </a:bodyPr>
+          <a:lstStyle/>
+          <a:p>
+            <a:pPr algn="l">
+              <a:spcBef>
+                <a:spcPts val="0"/>
+              </a:spcBef>
+              <a:spcAft>
+                <a:spcPts val="200"/>
+              </a:spcAft>
+            </a:pPr>
+            <a:r>
+              <a:rPr sz="1200" b="1" i="0">
+                <a:solidFill>
+                  <a:srgbClr val="5B6B78"/>
+                </a:solidFill>
+                <a:latin typeface="Calibri"/>
+              </a:rPr>
+              <a:t>Connect</a:t>
+            </a:r>
+          </a:p>
+        </p:txBody>
+      </p:sp>
+      <p:sp>
+        <p:nvSpPr>
+          <p:cNvPr id="15" name="Rounded Rectangle 14"/>
+          <p:cNvSpPr/>
+          <p:nvPr/>
+        </p:nvSpPr>
+        <p:spPr>
+          <a:xfrm>
+            <a:off x="3399967" y="3108960"/>
+            <a:ext cx="2558719" cy="2331720"/>
+          </a:xfrm>
+          <a:prstGeom prst="roundRect">
+            <a:avLst>
+              <a:gd name="adj" fmla="val 5000"/>
+            </a:avLst>
+          </a:prstGeom>
+          <a:solidFill>
+            <a:srgbClr val="F1F5F8"/>
+          </a:solidFill>
+          <a:ln>
+            <a:noFill/>
+          </a:ln>
+          <a:effectLst/>
+        </p:spPr>
+        <p:style>
+          <a:lnRef idx="1">
+            <a:schemeClr val="accent1"/>
+          </a:lnRef>
+          <a:fillRef idx="3">
+            <a:schemeClr val="accent1"/>
+          </a:fillRef>
+          <a:effectRef idx="2">
+            <a:schemeClr val="accent1"/>
+          </a:effectRef>
+          <a:fontRef idx="minor">
+            <a:schemeClr val="lt1"/>
+          </a:fontRef>
+        </p:style>
+        <p:txBody>
+          <a:bodyPr rtlCol="0" anchor="ctr"/>
+          <a:lstStyle/>
+          <a:p>
+            <a:pPr algn="ctr"/>
+            <a:endParaRPr/>
+          </a:p>
+        </p:txBody>
+      </p:sp>
+      <p:sp>
+        <p:nvSpPr>
+          <p:cNvPr id="16" name="Rounded Rectangle 15"/>
+          <p:cNvSpPr/>
+          <p:nvPr/>
+        </p:nvSpPr>
+        <p:spPr>
+          <a:xfrm>
+            <a:off x="3399967" y="3108960"/>
+            <a:ext cx="2558719" cy="475488"/>
+          </a:xfrm>
+          <a:prstGeom prst="roundRect">
+            <a:avLst>
+              <a:gd name="adj" fmla="val 8000"/>
+            </a:avLst>
+          </a:prstGeom>
+          <a:solidFill>
+            <a:srgbClr val="196B24"/>
+          </a:solidFill>
+          <a:ln>
+            <a:noFill/>
+          </a:ln>
+          <a:effectLst/>
+        </p:spPr>
+        <p:style>
+          <a:lnRef idx="1">
+            <a:schemeClr val="accent1"/>
+          </a:lnRef>
+          <a:fillRef idx="3">
+            <a:schemeClr val="accent1"/>
+          </a:fillRef>
+          <a:effectRef idx="2">
+            <a:schemeClr val="accent1"/>
+          </a:effectRef>
+          <a:fontRef idx="minor">
+            <a:schemeClr val="lt1"/>
+          </a:fontRef>
+        </p:style>
+        <p:txBody>
+          <a:bodyPr rtlCol="0" anchor="ctr"/>
+          <a:lstStyle/>
+          <a:p>
+            <a:pPr algn="ctr"/>
+            <a:endParaRPr/>
+          </a:p>
+        </p:txBody>
+      </p:sp>
+      <p:sp>
+        <p:nvSpPr>
+          <p:cNvPr id="17" name="TextBox 16"/>
+          <p:cNvSpPr txBox="1"/>
+          <p:nvPr/>
+        </p:nvSpPr>
+        <p:spPr>
+          <a:xfrm>
+            <a:off x="3564559" y="3163824"/>
+            <a:ext cx="2284399" cy="365760"/>
+          </a:xfrm>
+          <a:prstGeom prst="rect">
+            <a:avLst/>
+          </a:prstGeom>
+          <a:noFill/>
+        </p:spPr>
+        <p:txBody>
+          <a:bodyPr wrap="square" lIns="0" tIns="0" rIns="0" bIns="0" anchor="ctr">
+            <a:noAutofit/>
+          </a:bodyPr>
+          <a:lstStyle/>
+          <a:p>
+            <a:pPr algn="l">
+              <a:spcBef>
+                <a:spcPts val="0"/>
+              </a:spcBef>
+              <a:spcAft>
+                <a:spcPts val="200"/>
+              </a:spcAft>
+            </a:pPr>
+            <a:r>
+              <a:rPr sz="1400" b="1" i="0">
+                <a:solidFill>
+                  <a:srgbClr val="FFFFFF"/>
+                </a:solidFill>
+                <a:latin typeface="Calibri"/>
+              </a:rPr>
+              <a:t>Build &amp; deploy</a:t>
+            </a:r>
+          </a:p>
+        </p:txBody>
+      </p:sp>
+      <p:sp>
+        <p:nvSpPr>
+          <p:cNvPr id="18" name="TextBox 17"/>
+          <p:cNvSpPr txBox="1"/>
+          <p:nvPr/>
+        </p:nvSpPr>
+        <p:spPr>
+          <a:xfrm>
+            <a:off x="3564559" y="3703320"/>
+            <a:ext cx="2284399" cy="274320"/>
+          </a:xfrm>
+          <a:prstGeom prst="rect">
+            <a:avLst/>
+          </a:prstGeom>
+          <a:noFill/>
+        </p:spPr>
+        <p:txBody>
+          <a:bodyPr wrap="square" lIns="0" tIns="0" rIns="0" bIns="0" anchor="t">
+            <a:noAutofit/>
+          </a:bodyPr>
+          <a:lstStyle/>
+          <a:p>
+            <a:pPr algn="l">
+              <a:spcBef>
+                <a:spcPts val="0"/>
+              </a:spcBef>
+              <a:spcAft>
+                <a:spcPts val="200"/>
+              </a:spcAft>
+            </a:pPr>
+            <a:r>
+              <a:rPr sz="1200" b="1" i="0">
+                <a:solidFill>
+                  <a:srgbClr val="196B24"/>
+                </a:solidFill>
+                <a:latin typeface="Consolas"/>
+              </a:rPr>
+              <a:t>-tags spark</a:t>
+            </a:r>
+          </a:p>
+        </p:txBody>
+      </p:sp>
+      <p:sp>
+        <p:nvSpPr>
+          <p:cNvPr id="19" name="TextBox 18"/>
+          <p:cNvSpPr txBox="1"/>
+          <p:nvPr/>
+        </p:nvSpPr>
+        <p:spPr>
+          <a:xfrm>
+            <a:off x="3564559" y="4041648"/>
+            <a:ext cx="2229535" cy="914400"/>
+          </a:xfrm>
+          <a:prstGeom prst="rect">
+            <a:avLst/>
+          </a:prstGeom>
+          <a:noFill/>
+        </p:spPr>
+        <p:txBody>
+          <a:bodyPr wrap="square" lIns="0" tIns="0" rIns="0" bIns="0" anchor="t">
+            <a:noAutofit/>
+          </a:bodyPr>
+          <a:lstStyle/>
+          <a:p>
+            <a:pPr algn="l">
+              <a:spcBef>
+                <a:spcPts val="0"/>
+              </a:spcBef>
+              <a:spcAft>
+                <a:spcPts val="200"/>
+              </a:spcAft>
+            </a:pPr>
+            <a:r>
+              <a:rPr sz="1200" b="0" i="0">
+                <a:solidFill>
+                  <a:srgbClr val="1E2B36"/>
+                </a:solidFill>
+                <a:latin typeface="Calibri"/>
+              </a:rPr>
+              <a:t>Placeholders inlined — Spark Connect's Sql takes no bind parameters.</a:t>
+            </a:r>
+          </a:p>
+        </p:txBody>
+      </p:sp>
+      <p:sp>
+        <p:nvSpPr>
+          <p:cNvPr id="20" name="TextBox 19"/>
+          <p:cNvSpPr txBox="1"/>
+          <p:nvPr/>
+        </p:nvSpPr>
+        <p:spPr>
+          <a:xfrm>
+            <a:off x="3564559" y="5074920"/>
+            <a:ext cx="2284399" cy="274320"/>
+          </a:xfrm>
+          <a:prstGeom prst="rect">
+            <a:avLst/>
+          </a:prstGeom>
+          <a:noFill/>
+        </p:spPr>
+        <p:txBody>
+          <a:bodyPr wrap="square" lIns="0" tIns="0" rIns="0" bIns="0" anchor="t">
+            <a:noAutofit/>
+          </a:bodyPr>
+          <a:lstStyle/>
+          <a:p>
+            <a:pPr algn="l">
+              <a:spcBef>
+                <a:spcPts val="0"/>
+              </a:spcBef>
+              <a:spcAft>
+                <a:spcPts val="200"/>
+              </a:spcAft>
+            </a:pPr>
+            <a:r>
+              <a:rPr sz="1200" b="1" i="0">
+                <a:solidFill>
+                  <a:srgbClr val="5B6B78"/>
+                </a:solidFill>
+                <a:latin typeface="Calibri"/>
+              </a:rPr>
+              <a:t>no params</a:t>
+            </a:r>
+          </a:p>
+        </p:txBody>
+      </p:sp>
+      <p:sp>
+        <p:nvSpPr>
+          <p:cNvPr id="21" name="Rounded Rectangle 20"/>
+          <p:cNvSpPr/>
+          <p:nvPr/>
+        </p:nvSpPr>
+        <p:spPr>
+          <a:xfrm>
+            <a:off x="6233007" y="3108960"/>
+            <a:ext cx="2558719" cy="2331720"/>
+          </a:xfrm>
+          <a:prstGeom prst="roundRect">
+            <a:avLst>
+              <a:gd name="adj" fmla="val 5000"/>
+            </a:avLst>
+          </a:prstGeom>
+          <a:solidFill>
+            <a:srgbClr val="F1F5F8"/>
+          </a:solidFill>
+          <a:ln>
+            <a:noFill/>
+          </a:ln>
+          <a:effectLst/>
+        </p:spPr>
+        <p:style>
+          <a:lnRef idx="1">
+            <a:schemeClr val="accent1"/>
+          </a:lnRef>
+          <a:fillRef idx="3">
+            <a:schemeClr val="accent1"/>
+          </a:fillRef>
+          <a:effectRef idx="2">
+            <a:schemeClr val="accent1"/>
+          </a:effectRef>
+          <a:fontRef idx="minor">
+            <a:schemeClr val="lt1"/>
+          </a:fontRef>
+        </p:style>
+        <p:txBody>
+          <a:bodyPr rtlCol="0" anchor="ctr"/>
+          <a:lstStyle/>
+          <a:p>
+            <a:pPr algn="ctr"/>
+            <a:endParaRPr/>
+          </a:p>
+        </p:txBody>
+      </p:sp>
+      <p:sp>
+        <p:nvSpPr>
+          <p:cNvPr id="22" name="Rounded Rectangle 21"/>
+          <p:cNvSpPr/>
+          <p:nvPr/>
+        </p:nvSpPr>
+        <p:spPr>
+          <a:xfrm>
+            <a:off x="6233007" y="3108960"/>
+            <a:ext cx="2558719" cy="475488"/>
+          </a:xfrm>
+          <a:prstGeom prst="roundRect">
+            <a:avLst>
+              <a:gd name="adj" fmla="val 8000"/>
+            </a:avLst>
+          </a:prstGeom>
+          <a:solidFill>
+            <a:srgbClr val="E97132"/>
+          </a:solidFill>
+          <a:ln>
+            <a:noFill/>
+          </a:ln>
+          <a:effectLst/>
+        </p:spPr>
+        <p:style>
+          <a:lnRef idx="1">
+            <a:schemeClr val="accent1"/>
+          </a:lnRef>
+          <a:fillRef idx="3">
+            <a:schemeClr val="accent1"/>
+          </a:fillRef>
+          <a:effectRef idx="2">
+            <a:schemeClr val="accent1"/>
+          </a:effectRef>
+          <a:fontRef idx="minor">
+            <a:schemeClr val="lt1"/>
+          </a:fontRef>
+        </p:style>
+        <p:txBody>
+          <a:bodyPr rtlCol="0" anchor="ctr"/>
+          <a:lstStyle/>
+          <a:p>
+            <a:pPr algn="ctr"/>
+            <a:endParaRPr/>
+          </a:p>
+        </p:txBody>
+      </p:sp>
+      <p:sp>
+        <p:nvSpPr>
+          <p:cNvPr id="23" name="TextBox 22"/>
+          <p:cNvSpPr txBox="1"/>
+          <p:nvPr/>
+        </p:nvSpPr>
+        <p:spPr>
+          <a:xfrm>
+            <a:off x="6397599" y="3163824"/>
+            <a:ext cx="2284399" cy="365760"/>
+          </a:xfrm>
+          <a:prstGeom prst="rect">
+            <a:avLst/>
+          </a:prstGeom>
+          <a:noFill/>
+        </p:spPr>
+        <p:txBody>
+          <a:bodyPr wrap="square" lIns="0" tIns="0" rIns="0" bIns="0" anchor="ctr">
+            <a:noAutofit/>
+          </a:bodyPr>
+          <a:lstStyle/>
+          <a:p>
+            <a:pPr algn="l">
+              <a:spcBef>
+                <a:spcPts val="0"/>
+              </a:spcBef>
+              <a:spcAft>
+                <a:spcPts val="200"/>
+              </a:spcAft>
+            </a:pPr>
+            <a:r>
+              <a:rPr sz="1400" b="1" i="0">
+                <a:solidFill>
+                  <a:srgbClr val="FFFFFF"/>
+                </a:solidFill>
+                <a:latin typeface="Calibri"/>
+              </a:rPr>
+              <a:t>SQL dialect</a:t>
+            </a:r>
+          </a:p>
+        </p:txBody>
+      </p:sp>
+      <p:sp>
+        <p:nvSpPr>
+          <p:cNvPr id="24" name="TextBox 23"/>
+          <p:cNvSpPr txBox="1"/>
+          <p:nvPr/>
+        </p:nvSpPr>
+        <p:spPr>
+          <a:xfrm>
+            <a:off x="6397599" y="3703320"/>
+            <a:ext cx="2284399" cy="274320"/>
+          </a:xfrm>
+          <a:prstGeom prst="rect">
+            <a:avLst/>
+          </a:prstGeom>
+          <a:noFill/>
+        </p:spPr>
+        <p:txBody>
+          <a:bodyPr wrap="square" lIns="0" tIns="0" rIns="0" bIns="0" anchor="t">
+            <a:noAutofit/>
+          </a:bodyPr>
+          <a:lstStyle/>
+          <a:p>
+            <a:pPr algn="l">
+              <a:spcBef>
+                <a:spcPts val="0"/>
+              </a:spcBef>
+              <a:spcAft>
+                <a:spcPts val="200"/>
+              </a:spcAft>
+            </a:pPr>
+            <a:r>
+              <a:rPr sz="1200" b="1" i="0">
+                <a:solidFill>
+                  <a:srgbClr val="E97132"/>
+                </a:solidFill>
+                <a:latin typeface="Consolas"/>
+              </a:rPr>
+              <a:t>identity</a:t>
+            </a:r>
+          </a:p>
+        </p:txBody>
+      </p:sp>
+      <p:sp>
+        <p:nvSpPr>
+          <p:cNvPr id="25" name="TextBox 24"/>
+          <p:cNvSpPr txBox="1"/>
+          <p:nvPr/>
+        </p:nvSpPr>
+        <p:spPr>
+          <a:xfrm>
+            <a:off x="6397599" y="4041648"/>
+            <a:ext cx="2229535" cy="914400"/>
+          </a:xfrm>
+          <a:prstGeom prst="rect">
+            <a:avLst/>
+          </a:prstGeom>
+          <a:noFill/>
+        </p:spPr>
+        <p:txBody>
+          <a:bodyPr wrap="square" lIns="0" tIns="0" rIns="0" bIns="0" anchor="t">
+            <a:noAutofit/>
+          </a:bodyPr>
+          <a:lstStyle/>
+          <a:p>
+            <a:pPr algn="l">
+              <a:spcBef>
+                <a:spcPts val="0"/>
+              </a:spcBef>
+              <a:spcAft>
+                <a:spcPts val="200"/>
+              </a:spcAft>
+            </a:pPr>
+            <a:r>
+              <a:rPr sz="1200" b="0" i="0">
+                <a:solidFill>
+                  <a:srgbClr val="1E2B36"/>
+                </a:solidFill>
+                <a:latin typeface="Calibri"/>
+              </a:rPr>
+              <a:t>The canonical SQL names verbatim, like PostgreSQL and DuckDB; box accessors dispatch stbox vs tbox in one UDF via the WKB type tag.</a:t>
+            </a:r>
+          </a:p>
+        </p:txBody>
+      </p:sp>
+      <p:sp>
+        <p:nvSpPr>
+          <p:cNvPr id="26" name="TextBox 25"/>
+          <p:cNvSpPr txBox="1"/>
+          <p:nvPr/>
+        </p:nvSpPr>
+        <p:spPr>
+          <a:xfrm>
+            <a:off x="6397599" y="5074920"/>
+            <a:ext cx="2284399" cy="274320"/>
+          </a:xfrm>
+          <a:prstGeom prst="rect">
+            <a:avLst/>
+          </a:prstGeom>
+          <a:noFill/>
+        </p:spPr>
+        <p:txBody>
+          <a:bodyPr wrap="square" lIns="0" tIns="0" rIns="0" bIns="0" anchor="t">
+            <a:noAutofit/>
+          </a:bodyPr>
+          <a:lstStyle/>
+          <a:p>
+            <a:pPr algn="l">
+              <a:spcBef>
+                <a:spcPts val="0"/>
+              </a:spcBef>
+              <a:spcAft>
+                <a:spcPts val="200"/>
+              </a:spcAft>
+            </a:pPr>
+            <a:r>
+              <a:rPr sz="1200" b="1" i="0">
+                <a:solidFill>
+                  <a:srgbClr val="5B6B78"/>
+                </a:solidFill>
+                <a:latin typeface="Calibri"/>
+              </a:rPr>
+              <a:t>as-is</a:t>
+            </a:r>
+          </a:p>
+        </p:txBody>
+      </p:sp>
+      <p:sp>
+        <p:nvSpPr>
+          <p:cNvPr id="27" name="Rounded Rectangle 26"/>
+          <p:cNvSpPr/>
+          <p:nvPr/>
+        </p:nvSpPr>
+        <p:spPr>
+          <a:xfrm>
+            <a:off x="9066047" y="3108960"/>
+            <a:ext cx="2558719" cy="2331720"/>
+          </a:xfrm>
+          <a:prstGeom prst="roundRect">
+            <a:avLst>
+              <a:gd name="adj" fmla="val 5000"/>
+            </a:avLst>
+          </a:prstGeom>
+          <a:solidFill>
+            <a:srgbClr val="F1F5F8"/>
+          </a:solidFill>
+          <a:ln>
+            <a:noFill/>
+          </a:ln>
+          <a:effectLst/>
+        </p:spPr>
+        <p:style>
+          <a:lnRef idx="1">
+            <a:schemeClr val="accent1"/>
+          </a:lnRef>
+          <a:fillRef idx="3">
+            <a:schemeClr val="accent1"/>
+          </a:fillRef>
+          <a:effectRef idx="2">
+            <a:schemeClr val="accent1"/>
+          </a:effectRef>
+          <a:fontRef idx="minor">
+            <a:schemeClr val="lt1"/>
+          </a:fontRef>
+        </p:style>
+        <p:txBody>
+          <a:bodyPr rtlCol="0" anchor="ctr"/>
+          <a:lstStyle/>
+          <a:p>
+            <a:pPr algn="ctr"/>
+            <a:endParaRPr/>
+          </a:p>
+        </p:txBody>
+      </p:sp>
+      <p:sp>
+        <p:nvSpPr>
+          <p:cNvPr id="28" name="Rounded Rectangle 27"/>
+          <p:cNvSpPr/>
+          <p:nvPr/>
+        </p:nvSpPr>
+        <p:spPr>
+          <a:xfrm>
+            <a:off x="9066047" y="3108960"/>
+            <a:ext cx="2558719" cy="475488"/>
+          </a:xfrm>
+          <a:prstGeom prst="roundRect">
+            <a:avLst>
+              <a:gd name="adj" fmla="val 8000"/>
+            </a:avLst>
+          </a:prstGeom>
+          <a:solidFill>
+            <a:srgbClr val="A02B93"/>
+          </a:solidFill>
+          <a:ln>
+            <a:noFill/>
+          </a:ln>
+          <a:effectLst/>
+        </p:spPr>
+        <p:style>
+          <a:lnRef idx="1">
+            <a:schemeClr val="accent1"/>
+          </a:lnRef>
+          <a:fillRef idx="3">
+            <a:schemeClr val="accent1"/>
+          </a:fillRef>
+          <a:effectRef idx="2">
+            <a:schemeClr val="accent1"/>
+          </a:effectRef>
+          <a:fontRef idx="minor">
+            <a:schemeClr val="lt1"/>
+          </a:fontRef>
+        </p:style>
+        <p:txBody>
+          <a:bodyPr rtlCol="0" anchor="ctr"/>
+          <a:lstStyle/>
+          <a:p>
+            <a:pPr algn="ctr"/>
+            <a:endParaRPr/>
+          </a:p>
+        </p:txBody>
+      </p:sp>
+      <p:sp>
+        <p:nvSpPr>
+          <p:cNvPr id="29" name="TextBox 28"/>
+          <p:cNvSpPr txBox="1"/>
+          <p:nvPr/>
+        </p:nvSpPr>
+        <p:spPr>
+          <a:xfrm>
+            <a:off x="9230639" y="3163824"/>
+            <a:ext cx="2284399" cy="365760"/>
+          </a:xfrm>
+          <a:prstGeom prst="rect">
+            <a:avLst/>
+          </a:prstGeom>
+          <a:noFill/>
+        </p:spPr>
+        <p:txBody>
+          <a:bodyPr wrap="square" lIns="0" tIns="0" rIns="0" bIns="0" anchor="ctr">
+            <a:noAutofit/>
+          </a:bodyPr>
+          <a:lstStyle/>
+          <a:p>
+            <a:pPr algn="l">
+              <a:spcBef>
+                <a:spcPts val="0"/>
+              </a:spcBef>
+              <a:spcAft>
+                <a:spcPts val="200"/>
+              </a:spcAft>
+            </a:pPr>
+            <a:r>
+              <a:rPr sz="1400" b="1" i="0">
+                <a:solidFill>
+                  <a:srgbClr val="FFFFFF"/>
+                </a:solidFill>
+                <a:latin typeface="Calibri"/>
+              </a:rPr>
+              <a:t>Sweet spot</a:t>
+            </a:r>
+          </a:p>
+        </p:txBody>
+      </p:sp>
+      <p:sp>
+        <p:nvSpPr>
+          <p:cNvPr id="30" name="TextBox 29"/>
+          <p:cNvSpPr txBox="1"/>
+          <p:nvPr/>
+        </p:nvSpPr>
+        <p:spPr>
+          <a:xfrm>
+            <a:off x="9230639" y="3703320"/>
+            <a:ext cx="2284399" cy="274320"/>
+          </a:xfrm>
+          <a:prstGeom prst="rect">
+            <a:avLst/>
+          </a:prstGeom>
+          <a:noFill/>
+        </p:spPr>
+        <p:txBody>
+          <a:bodyPr wrap="square" lIns="0" tIns="0" rIns="0" bIns="0" anchor="t">
+            <a:noAutofit/>
+          </a:bodyPr>
+          <a:lstStyle/>
+          <a:p>
+            <a:pPr algn="l">
+              <a:spcBef>
+                <a:spcPts val="0"/>
+              </a:spcBef>
+              <a:spcAft>
+                <a:spcPts val="200"/>
+              </a:spcAft>
+            </a:pPr>
+            <a:r>
+              <a:rPr sz="1200" b="1" i="0">
+                <a:solidFill>
+                  <a:srgbClr val="A02B93"/>
+                </a:solidFill>
+                <a:latin typeface="Consolas"/>
+              </a:rPr>
+              <a:t>distributed</a:t>
+            </a:r>
+          </a:p>
+        </p:txBody>
+      </p:sp>
+      <p:sp>
+        <p:nvSpPr>
+          <p:cNvPr id="31" name="TextBox 30"/>
+          <p:cNvSpPr txBox="1"/>
+          <p:nvPr/>
+        </p:nvSpPr>
+        <p:spPr>
+          <a:xfrm>
+            <a:off x="9230639" y="4041648"/>
+            <a:ext cx="2229535" cy="914400"/>
+          </a:xfrm>
+          <a:prstGeom prst="rect">
+            <a:avLst/>
+          </a:prstGeom>
+          <a:noFill/>
+        </p:spPr>
+        <p:txBody>
+          <a:bodyPr wrap="square" lIns="0" tIns="0" rIns="0" bIns="0" anchor="t">
+            <a:noAutofit/>
+          </a:bodyPr>
+          <a:lstStyle/>
+          <a:p>
+            <a:pPr algn="l">
+              <a:spcBef>
+                <a:spcPts val="0"/>
+              </a:spcBef>
+              <a:spcAft>
+                <a:spcPts val="200"/>
+              </a:spcAft>
+            </a:pPr>
+            <a:r>
+              <a:rPr sz="1200" b="0" i="0">
+                <a:solidFill>
+                  <a:srgbClr val="1E2B36"/>
+                </a:solidFill>
+                <a:latin typeface="Calibri"/>
+              </a:rPr>
+              <a:t>Batch analytics over very large histories; th3index per-engine spatial indexing.</a:t>
+            </a:r>
+          </a:p>
+        </p:txBody>
+      </p:sp>
+      <p:sp>
+        <p:nvSpPr>
+          <p:cNvPr id="32" name="TextBox 31"/>
+          <p:cNvSpPr txBox="1"/>
+          <p:nvPr/>
+        </p:nvSpPr>
+        <p:spPr>
+          <a:xfrm>
+            <a:off x="9230639" y="5074920"/>
+            <a:ext cx="2284399" cy="274320"/>
+          </a:xfrm>
+          <a:prstGeom prst="rect">
+            <a:avLst/>
+          </a:prstGeom>
+          <a:noFill/>
+        </p:spPr>
+        <p:txBody>
+          <a:bodyPr wrap="square" lIns="0" tIns="0" rIns="0" bIns="0" anchor="t">
+            <a:noAutofit/>
+          </a:bodyPr>
+          <a:lstStyle/>
+          <a:p>
+            <a:pPr algn="l">
+              <a:spcBef>
+                <a:spcPts val="0"/>
+              </a:spcBef>
+              <a:spcAft>
+                <a:spcPts val="200"/>
+              </a:spcAft>
+            </a:pPr>
+            <a:r>
+              <a:rPr sz="1200" b="1" i="0">
+                <a:solidFill>
+                  <a:srgbClr val="5B6B78"/>
+                </a:solidFill>
+                <a:latin typeface="Calibri"/>
+              </a:rPr>
+              <a:t>th3index</a:t>
+            </a:r>
+          </a:p>
+        </p:txBody>
+      </p:sp>
+      <p:sp>
+        <p:nvSpPr>
+          <p:cNvPr id="33" name="TextBox 32"/>
+          <p:cNvSpPr txBox="1"/>
+          <p:nvPr/>
+        </p:nvSpPr>
+        <p:spPr>
+          <a:xfrm>
+            <a:off x="566928" y="5669280"/>
+            <a:ext cx="11057839" cy="640080"/>
+          </a:xfrm>
+          <a:prstGeom prst="rect">
+            <a:avLst/>
+          </a:prstGeom>
+          <a:noFill/>
+        </p:spPr>
+        <p:txBody>
+          <a:bodyPr wrap="square" lIns="0" tIns="0" rIns="0" bIns="0" anchor="t">
+            <a:noAutofit/>
+          </a:bodyPr>
+          <a:lstStyle/>
+          <a:p>
+            <a:pPr algn="ctr">
+              <a:spcBef>
+                <a:spcPts val="0"/>
+              </a:spcBef>
+              <a:spcAft>
+                <a:spcPts val="200"/>
+              </a:spcAft>
+            </a:pPr>
+            <a:r>
+              <a:rPr sz="1200" b="0" i="0">
+                <a:solidFill>
+                  <a:srgbClr val="5B6B78"/>
+                </a:solidFill>
+                <a:latin typeface="Calibri"/>
+              </a:rPr>
+              <a:t>Same thin tier and Go assembly; MobilitySpark registers the canonical SQL names verbatim, so the only per-engine step is inlining the placeholders Spark Connect does not bind.</a:t>
+            </a:r>
+          </a:p>
+        </p:txBody>
+      </p:sp>
+      <p:sp>
+        <p:nvSpPr>
+          <p:cNvPr id="34" name="Rectangle 33"/>
+          <p:cNvSpPr/>
+          <p:nvPr/>
+        </p:nvSpPr>
+        <p:spPr>
+          <a:xfrm>
+            <a:off x="566928" y="6455664"/>
+            <a:ext cx="11057839" cy="10972"/>
+          </a:xfrm>
+          <a:prstGeom prst="rect">
+            <a:avLst/>
+          </a:prstGeom>
+          <a:solidFill>
+            <a:srgbClr val="D3DEE6"/>
+          </a:solidFill>
+          <a:ln>
+            <a:noFill/>
+          </a:ln>
+          <a:effectLst/>
+        </p:spPr>
+        <p:style>
+          <a:lnRef idx="1">
+            <a:schemeClr val="accent1"/>
+          </a:lnRef>
+          <a:fillRef idx="3">
+            <a:schemeClr val="accent1"/>
+          </a:fillRef>
+          <a:effectRef idx="2">
+            <a:schemeClr val="accent1"/>
+          </a:effectRef>
+          <a:fontRef idx="minor">
+            <a:schemeClr val="lt1"/>
+          </a:fontRef>
+        </p:style>
+        <p:txBody>
+          <a:bodyPr rtlCol="0" anchor="ctr"/>
+          <a:lstStyle/>
+          <a:p>
+            <a:pPr algn="ctr"/>
+            <a:endParaRPr/>
+          </a:p>
+        </p:txBody>
+      </p:sp>
+      <p:sp>
+        <p:nvSpPr>
+          <p:cNvPr id="35" name="TextBox 34"/>
+          <p:cNvSpPr txBox="1"/>
+          <p:nvPr/>
+        </p:nvSpPr>
+        <p:spPr>
+          <a:xfrm>
+            <a:off x="566928" y="6510528"/>
+            <a:ext cx="7315200" cy="274320"/>
+          </a:xfrm>
+          <a:prstGeom prst="rect">
+            <a:avLst/>
+          </a:prstGeom>
+          <a:noFill/>
+        </p:spPr>
+        <p:txBody>
+          <a:bodyPr wrap="square" lIns="0" tIns="0" rIns="0" bIns="0" anchor="t">
+            <a:noAutofit/>
+          </a:bodyPr>
+          <a:lstStyle/>
+          <a:p>
+            <a:pPr algn="l">
+              <a:spcBef>
+                <a:spcPts val="0"/>
+              </a:spcBef>
+              <a:spcAft>
+                <a:spcPts val="200"/>
+              </a:spcAft>
+            </a:pPr>
+            <a:r>
+              <a:rPr sz="1200" b="0" i="0">
+                <a:solidFill>
+                  <a:srgbClr val="5B6B78"/>
+                </a:solidFill>
+                <a:latin typeface="Calibri"/>
+              </a:rPr>
+              <a:t>MobilityAPI  ·  OGC API – Moving Features</a:t>
+            </a:r>
+          </a:p>
+        </p:txBody>
+      </p:sp>
+      <p:sp>
+        <p:nvSpPr>
+          <p:cNvPr id="36" name="TextBox 35"/>
+          <p:cNvSpPr txBox="1"/>
+          <p:nvPr/>
+        </p:nvSpPr>
+        <p:spPr>
+          <a:xfrm>
+            <a:off x="10911535" y="6510528"/>
+            <a:ext cx="731520" cy="274320"/>
+          </a:xfrm>
+          <a:prstGeom prst="rect">
+            <a:avLst/>
+          </a:prstGeom>
+          <a:noFill/>
+        </p:spPr>
+        <p:txBody>
+          <a:bodyPr wrap="square" lIns="0" tIns="0" rIns="0" bIns="0" anchor="t">
+            <a:noAutofit/>
+          </a:bodyPr>
+          <a:lstStyle/>
+          <a:p>
+            <a:pPr algn="r">
+              <a:spcBef>
+                <a:spcPts val="0"/>
+              </a:spcBef>
+              <a:spcAft>
+                <a:spcPts val="200"/>
+              </a:spcAft>
+            </a:pPr>
+            <a:r>
+              <a:rPr sz="1200" b="0" i="0">
+                <a:solidFill>
+                  <a:srgbClr val="5B6B78"/>
+                </a:solidFill>
+                <a:latin typeface="Calibri"/>
+              </a:rPr>
+              <a:t>28</a:t>
             </a:r>
           </a:p>
         </p:txBody>
@@ -34784,7 +39404,7 @@
                 </a:solidFill>
                 <a:latin typeface="Calibri"/>
               </a:rPr>
-              <a:t>04</a:t>
+              <a:t>4</a:t>
             </a:r>
           </a:p>
         </p:txBody>
@@ -35364,7 +39984,7 @@
                 </a:solidFill>
                 <a:latin typeface="Calibri"/>
               </a:rPr>
-              <a:t>05</a:t>
+              <a:t>5</a:t>
             </a:r>
           </a:p>
         </p:txBody>
@@ -35679,7 +40299,7 @@
                 </a:solidFill>
                 <a:latin typeface="Calibri"/>
               </a:rPr>
-              <a:t>06</a:t>
+              <a:t>6</a:t>
             </a:r>
           </a:p>
         </p:txBody>
@@ -35994,7 +40614,7 @@
                 </a:solidFill>
                 <a:latin typeface="Calibri"/>
               </a:rPr>
-              <a:t>07</a:t>
+              <a:t>7</a:t>
             </a:r>
           </a:p>
         </p:txBody>
@@ -37640,7 +42260,7 @@
                 </a:solidFill>
                 <a:latin typeface="Calibri"/>
               </a:rPr>
-              <a:t>08</a:t>
+              <a:t>8</a:t>
             </a:r>
           </a:p>
         </p:txBody>
@@ -38220,7 +42840,7 @@
                 </a:solidFill>
                 <a:latin typeface="Calibri"/>
               </a:rPr>
-              <a:t>09</a:t>
+              <a:t>9</a:t>
             </a:r>
           </a:p>
         </p:txBody>

</xml_diff>